<commit_message>
Pupil save guide with real Windows 11 screenshots; Work Area wording
Co-Authored-By: Claude Sonnet 5.5 <noreply@anthropic.com>
Claude-Session: https://claude.ai/code/session_017T1xmxXgaPmCqfeKLg7vXH
</commit_message>
<xml_diff>
--- a/resources/Year-3/Saving work in your own folder - pupil guide.pptx
+++ b/resources/Year-3/Saving work in your own folder - pupil guide.pptx
@@ -1397,7 +1397,7 @@
           <a:p>
             <a:r>
               <a:rPr lang="en-US" dirty="0"/>
-              <a:t>On school computers File Explorer is the yellow folder icon in the taskbar.</a:t>
+              <a:t/>
             </a:r>
             <a:endParaRPr lang="en-US" dirty="0"/>
           </a:p>
@@ -1485,7 +1485,7 @@
           <a:p>
             <a:r>
               <a:rPr lang="en-US" dirty="0"/>
-              <a:t>Right-click = press the right mouse button. On a touchpad: two fingers. Change Y3 to the class (Y4, etc.).</a:t>
+              <a:t/>
             </a:r>
             <a:endParaRPr lang="en-US" dirty="0"/>
           </a:p>
@@ -1573,7 +1573,7 @@
           <a:p>
             <a:r>
               <a:rPr lang="en-US" dirty="0"/>
-              <a:t>The browser opens a Save box next. This is where the pupils choose the folder.</a:t>
+              <a:t/>
             </a:r>
             <a:endParaRPr lang="en-US" dirty="0"/>
           </a:p>
@@ -1661,7 +1661,7 @@
           <a:p>
             <a:r>
               <a:rPr lang="en-US" dirty="0"/>
-              <a:t>If the Save box does not open, the browser may save to Downloads. Then pupils drag the file from Downloads into their folder.</a:t>
+              <a:t/>
             </a:r>
             <a:endParaRPr lang="en-US" dirty="0"/>
           </a:p>
@@ -2520,7 +2520,7 @@
       </p:grpSpPr>
       <p:sp>
         <p:nvSpPr>
-          <p:cNvPr id="2" name="Accent 73"/>
+          <p:cNvPr id="2" name="Accent 59"/>
           <p:cNvSpPr/>
           <p:nvPr/>
         </p:nvSpPr>
@@ -2545,7 +2545,7 @@
       </p:sp>
       <p:sp>
         <p:nvSpPr>
-          <p:cNvPr id="3" name="Text 74"/>
+          <p:cNvPr id="3" name="Text 60"/>
           <p:cNvSpPr txBox="1"/>
           <p:nvPr/>
         </p:nvSpPr>
@@ -2584,7 +2584,7 @@
       </p:sp>
       <p:sp>
         <p:nvSpPr>
-          <p:cNvPr id="4" name="Text 75"/>
+          <p:cNvPr id="4" name="Text 61"/>
           <p:cNvSpPr txBox="1"/>
           <p:nvPr/>
         </p:nvSpPr>
@@ -2623,7 +2623,7 @@
       </p:sp>
       <p:sp>
         <p:nvSpPr>
-          <p:cNvPr id="5" name="Card 76"/>
+          <p:cNvPr id="5" name="Card 62"/>
           <p:cNvSpPr/>
           <p:nvPr/>
         </p:nvSpPr>
@@ -2657,7 +2657,7 @@
       </p:sp>
       <p:sp>
         <p:nvSpPr>
-          <p:cNvPr id="6" name="Dot 77"/>
+          <p:cNvPr id="6" name="Dot 63"/>
           <p:cNvSpPr/>
           <p:nvPr/>
         </p:nvSpPr>
@@ -2682,7 +2682,7 @@
       </p:sp>
       <p:sp>
         <p:nvSpPr>
-          <p:cNvPr id="7" name="Text 78"/>
+          <p:cNvPr id="7" name="Text 64"/>
           <p:cNvSpPr txBox="1"/>
           <p:nvPr/>
         </p:nvSpPr>
@@ -2721,7 +2721,7 @@
       </p:sp>
       <p:sp>
         <p:nvSpPr>
-          <p:cNvPr id="8" name="Text 79"/>
+          <p:cNvPr id="8" name="Text 65"/>
           <p:cNvSpPr txBox="1"/>
           <p:nvPr/>
         </p:nvSpPr>
@@ -2760,7 +2760,7 @@
       </p:sp>
       <p:sp>
         <p:nvSpPr>
-          <p:cNvPr id="9" name="Card 80"/>
+          <p:cNvPr id="9" name="Card 66"/>
           <p:cNvSpPr/>
           <p:nvPr/>
         </p:nvSpPr>
@@ -2794,7 +2794,7 @@
       </p:sp>
       <p:sp>
         <p:nvSpPr>
-          <p:cNvPr id="10" name="Dot 81"/>
+          <p:cNvPr id="10" name="Dot 67"/>
           <p:cNvSpPr/>
           <p:nvPr/>
         </p:nvSpPr>
@@ -2819,7 +2819,7 @@
       </p:sp>
       <p:sp>
         <p:nvSpPr>
-          <p:cNvPr id="11" name="Text 82"/>
+          <p:cNvPr id="11" name="Text 68"/>
           <p:cNvSpPr txBox="1"/>
           <p:nvPr/>
         </p:nvSpPr>
@@ -2858,7 +2858,7 @@
       </p:sp>
       <p:sp>
         <p:nvSpPr>
-          <p:cNvPr id="12" name="Text 83"/>
+          <p:cNvPr id="12" name="Text 69"/>
           <p:cNvSpPr txBox="1"/>
           <p:nvPr/>
         </p:nvSpPr>
@@ -2897,7 +2897,7 @@
       </p:sp>
       <p:sp>
         <p:nvSpPr>
-          <p:cNvPr id="13" name="Card 84"/>
+          <p:cNvPr id="13" name="Card 70"/>
           <p:cNvSpPr/>
           <p:nvPr/>
         </p:nvSpPr>
@@ -2931,7 +2931,7 @@
       </p:sp>
       <p:sp>
         <p:nvSpPr>
-          <p:cNvPr id="14" name="Dot 85"/>
+          <p:cNvPr id="14" name="Dot 71"/>
           <p:cNvSpPr/>
           <p:nvPr/>
         </p:nvSpPr>
@@ -2956,7 +2956,7 @@
       </p:sp>
       <p:sp>
         <p:nvSpPr>
-          <p:cNvPr id="15" name="Text 86"/>
+          <p:cNvPr id="15" name="Text 72"/>
           <p:cNvSpPr txBox="1"/>
           <p:nvPr/>
         </p:nvSpPr>
@@ -2995,7 +2995,7 @@
       </p:sp>
       <p:sp>
         <p:nvSpPr>
-          <p:cNvPr id="16" name="Text 87"/>
+          <p:cNvPr id="16" name="Text 73"/>
           <p:cNvSpPr txBox="1"/>
           <p:nvPr/>
         </p:nvSpPr>
@@ -3059,7 +3059,7 @@
       </p:grpSpPr>
       <p:sp>
         <p:nvSpPr>
-          <p:cNvPr id="2" name="Accent 88"/>
+          <p:cNvPr id="2" name="Accent 74"/>
           <p:cNvSpPr/>
           <p:nvPr/>
         </p:nvSpPr>
@@ -3084,7 +3084,7 @@
       </p:sp>
       <p:sp>
         <p:nvSpPr>
-          <p:cNvPr id="3" name="Text 89"/>
+          <p:cNvPr id="3" name="Text 75"/>
           <p:cNvSpPr txBox="1"/>
           <p:nvPr/>
         </p:nvSpPr>
@@ -3123,7 +3123,7 @@
       </p:sp>
       <p:sp>
         <p:nvSpPr>
-          <p:cNvPr id="4" name="Text 90"/>
+          <p:cNvPr id="4" name="Text 76"/>
           <p:cNvSpPr txBox="1"/>
           <p:nvPr/>
         </p:nvSpPr>
@@ -3162,7 +3162,7 @@
       </p:sp>
       <p:sp>
         <p:nvSpPr>
-          <p:cNvPr id="5" name="Card 91"/>
+          <p:cNvPr id="5" name="Card 77"/>
           <p:cNvSpPr/>
           <p:nvPr/>
         </p:nvSpPr>
@@ -3196,7 +3196,7 @@
       </p:sp>
       <p:sp>
         <p:nvSpPr>
-          <p:cNvPr id="6" name="Dot 92"/>
+          <p:cNvPr id="6" name="Dot 78"/>
           <p:cNvSpPr/>
           <p:nvPr/>
         </p:nvSpPr>
@@ -3221,7 +3221,7 @@
       </p:sp>
       <p:sp>
         <p:nvSpPr>
-          <p:cNvPr id="7" name="Text 93"/>
+          <p:cNvPr id="7" name="Text 79"/>
           <p:cNvSpPr txBox="1"/>
           <p:nvPr/>
         </p:nvSpPr>
@@ -3260,7 +3260,7 @@
       </p:sp>
       <p:sp>
         <p:nvSpPr>
-          <p:cNvPr id="8" name="Text 94"/>
+          <p:cNvPr id="8" name="Text 80"/>
           <p:cNvSpPr txBox="1"/>
           <p:nvPr/>
         </p:nvSpPr>
@@ -3299,7 +3299,7 @@
       </p:sp>
       <p:sp>
         <p:nvSpPr>
-          <p:cNvPr id="9" name="Card 95"/>
+          <p:cNvPr id="9" name="Card 81"/>
           <p:cNvSpPr/>
           <p:nvPr/>
         </p:nvSpPr>
@@ -3333,7 +3333,7 @@
       </p:sp>
       <p:sp>
         <p:nvSpPr>
-          <p:cNvPr id="10" name="Dot 96"/>
+          <p:cNvPr id="10" name="Dot 82"/>
           <p:cNvSpPr/>
           <p:nvPr/>
         </p:nvSpPr>
@@ -3358,7 +3358,7 @@
       </p:sp>
       <p:sp>
         <p:nvSpPr>
-          <p:cNvPr id="11" name="Text 97"/>
+          <p:cNvPr id="11" name="Text 83"/>
           <p:cNvSpPr txBox="1"/>
           <p:nvPr/>
         </p:nvSpPr>
@@ -3397,7 +3397,7 @@
       </p:sp>
       <p:sp>
         <p:nvSpPr>
-          <p:cNvPr id="12" name="Text 98"/>
+          <p:cNvPr id="12" name="Text 84"/>
           <p:cNvSpPr txBox="1"/>
           <p:nvPr/>
         </p:nvSpPr>
@@ -3436,7 +3436,7 @@
       </p:sp>
       <p:sp>
         <p:nvSpPr>
-          <p:cNvPr id="13" name="Card 99"/>
+          <p:cNvPr id="13" name="Card 85"/>
           <p:cNvSpPr/>
           <p:nvPr/>
         </p:nvSpPr>
@@ -3470,7 +3470,7 @@
       </p:sp>
       <p:sp>
         <p:nvSpPr>
-          <p:cNvPr id="14" name="Dot 100"/>
+          <p:cNvPr id="14" name="Dot 86"/>
           <p:cNvSpPr/>
           <p:nvPr/>
         </p:nvSpPr>
@@ -3495,7 +3495,7 @@
       </p:sp>
       <p:sp>
         <p:nvSpPr>
-          <p:cNvPr id="15" name="Text 101"/>
+          <p:cNvPr id="15" name="Text 87"/>
           <p:cNvSpPr txBox="1"/>
           <p:nvPr/>
         </p:nvSpPr>
@@ -3534,7 +3534,7 @@
       </p:sp>
       <p:sp>
         <p:nvSpPr>
-          <p:cNvPr id="16" name="Text 102"/>
+          <p:cNvPr id="16" name="Text 88"/>
           <p:cNvSpPr txBox="1"/>
           <p:nvPr/>
         </p:nvSpPr>
@@ -3573,7 +3573,7 @@
       </p:sp>
       <p:sp>
         <p:nvSpPr>
-          <p:cNvPr id="17" name="Text 103"/>
+          <p:cNvPr id="17" name="Text 89"/>
           <p:cNvSpPr txBox="1"/>
           <p:nvPr/>
         </p:nvSpPr>
@@ -3637,7 +3637,7 @@
       </p:grpSpPr>
       <p:sp>
         <p:nvSpPr>
-          <p:cNvPr id="2" name="Accent 104"/>
+          <p:cNvPr id="2" name="Accent 90"/>
           <p:cNvSpPr/>
           <p:nvPr/>
         </p:nvSpPr>
@@ -3662,7 +3662,7 @@
       </p:sp>
       <p:sp>
         <p:nvSpPr>
-          <p:cNvPr id="3" name="Text 105"/>
+          <p:cNvPr id="3" name="Text 91"/>
           <p:cNvSpPr txBox="1"/>
           <p:nvPr/>
         </p:nvSpPr>
@@ -3701,7 +3701,7 @@
       </p:sp>
       <p:sp>
         <p:nvSpPr>
-          <p:cNvPr id="4" name="Text 106"/>
+          <p:cNvPr id="4" name="Text 92"/>
           <p:cNvSpPr txBox="1"/>
           <p:nvPr/>
         </p:nvSpPr>
@@ -3740,7 +3740,7 @@
       </p:sp>
       <p:sp>
         <p:nvSpPr>
-          <p:cNvPr id="5" name="Card 107"/>
+          <p:cNvPr id="5" name="Card 93"/>
           <p:cNvSpPr/>
           <p:nvPr/>
         </p:nvSpPr>
@@ -3774,7 +3774,7 @@
       </p:sp>
       <p:sp>
         <p:nvSpPr>
-          <p:cNvPr id="6" name="Dot 108"/>
+          <p:cNvPr id="6" name="Dot 94"/>
           <p:cNvSpPr/>
           <p:nvPr/>
         </p:nvSpPr>
@@ -3799,7 +3799,7 @@
       </p:sp>
       <p:sp>
         <p:nvSpPr>
-          <p:cNvPr id="7" name="Text 109"/>
+          <p:cNvPr id="7" name="Text 95"/>
           <p:cNvSpPr txBox="1"/>
           <p:nvPr/>
         </p:nvSpPr>
@@ -3838,7 +3838,7 @@
       </p:sp>
       <p:sp>
         <p:nvSpPr>
-          <p:cNvPr id="8" name="Text 110"/>
+          <p:cNvPr id="8" name="Text 96"/>
           <p:cNvSpPr txBox="1"/>
           <p:nvPr/>
         </p:nvSpPr>
@@ -3877,7 +3877,7 @@
       </p:sp>
       <p:sp>
         <p:nvSpPr>
-          <p:cNvPr id="9" name="Card 111"/>
+          <p:cNvPr id="9" name="Card 97"/>
           <p:cNvSpPr/>
           <p:nvPr/>
         </p:nvSpPr>
@@ -3911,7 +3911,7 @@
       </p:sp>
       <p:sp>
         <p:nvSpPr>
-          <p:cNvPr id="10" name="Dot 112"/>
+          <p:cNvPr id="10" name="Dot 98"/>
           <p:cNvSpPr/>
           <p:nvPr/>
         </p:nvSpPr>
@@ -3936,7 +3936,7 @@
       </p:sp>
       <p:sp>
         <p:nvSpPr>
-          <p:cNvPr id="11" name="Text 113"/>
+          <p:cNvPr id="11" name="Text 99"/>
           <p:cNvSpPr txBox="1"/>
           <p:nvPr/>
         </p:nvSpPr>
@@ -3975,7 +3975,7 @@
       </p:sp>
       <p:sp>
         <p:nvSpPr>
-          <p:cNvPr id="12" name="Text 114"/>
+          <p:cNvPr id="12" name="Text 100"/>
           <p:cNvSpPr txBox="1"/>
           <p:nvPr/>
         </p:nvSpPr>
@@ -4014,7 +4014,7 @@
       </p:sp>
       <p:sp>
         <p:nvSpPr>
-          <p:cNvPr id="13" name="Card 115"/>
+          <p:cNvPr id="13" name="Card 101"/>
           <p:cNvSpPr/>
           <p:nvPr/>
         </p:nvSpPr>
@@ -4048,7 +4048,7 @@
       </p:sp>
       <p:sp>
         <p:nvSpPr>
-          <p:cNvPr id="14" name="Dot 116"/>
+          <p:cNvPr id="14" name="Dot 102"/>
           <p:cNvSpPr/>
           <p:nvPr/>
         </p:nvSpPr>
@@ -4073,7 +4073,7 @@
       </p:sp>
       <p:sp>
         <p:nvSpPr>
-          <p:cNvPr id="15" name="Text 117"/>
+          <p:cNvPr id="15" name="Text 103"/>
           <p:cNvSpPr txBox="1"/>
           <p:nvPr/>
         </p:nvSpPr>
@@ -4112,7 +4112,7 @@
       </p:sp>
       <p:sp>
         <p:nvSpPr>
-          <p:cNvPr id="16" name="Text 118"/>
+          <p:cNvPr id="16" name="Text 104"/>
           <p:cNvSpPr txBox="1"/>
           <p:nvPr/>
         </p:nvSpPr>
@@ -4176,7 +4176,7 @@
       </p:grpSpPr>
       <p:sp>
         <p:nvSpPr>
-          <p:cNvPr id="2" name="Accent 119"/>
+          <p:cNvPr id="2" name="Accent 105"/>
           <p:cNvSpPr/>
           <p:nvPr/>
         </p:nvSpPr>
@@ -4201,7 +4201,7 @@
       </p:sp>
       <p:sp>
         <p:nvSpPr>
-          <p:cNvPr id="3" name="Text 120"/>
+          <p:cNvPr id="3" name="Text 106"/>
           <p:cNvSpPr txBox="1"/>
           <p:nvPr/>
         </p:nvSpPr>
@@ -4240,7 +4240,7 @@
       </p:sp>
       <p:sp>
         <p:nvSpPr>
-          <p:cNvPr id="4" name="Text 121"/>
+          <p:cNvPr id="4" name="Text 107"/>
           <p:cNvSpPr txBox="1"/>
           <p:nvPr/>
         </p:nvSpPr>
@@ -4279,7 +4279,7 @@
       </p:sp>
       <p:sp>
         <p:nvSpPr>
-          <p:cNvPr id="5" name="Card 122"/>
+          <p:cNvPr id="5" name="Card 108"/>
           <p:cNvSpPr/>
           <p:nvPr/>
         </p:nvSpPr>
@@ -4313,7 +4313,7 @@
       </p:sp>
       <p:sp>
         <p:nvSpPr>
-          <p:cNvPr id="6" name="Dot 123"/>
+          <p:cNvPr id="6" name="Dot 109"/>
           <p:cNvSpPr/>
           <p:nvPr/>
         </p:nvSpPr>
@@ -4338,7 +4338,7 @@
       </p:sp>
       <p:sp>
         <p:nvSpPr>
-          <p:cNvPr id="7" name="Text 124"/>
+          <p:cNvPr id="7" name="Text 110"/>
           <p:cNvSpPr txBox="1"/>
           <p:nvPr/>
         </p:nvSpPr>
@@ -4377,7 +4377,7 @@
       </p:sp>
       <p:sp>
         <p:nvSpPr>
-          <p:cNvPr id="8" name="Text 125"/>
+          <p:cNvPr id="8" name="Text 111"/>
           <p:cNvSpPr txBox="1"/>
           <p:nvPr/>
         </p:nvSpPr>
@@ -4416,7 +4416,7 @@
       </p:sp>
       <p:sp>
         <p:nvSpPr>
-          <p:cNvPr id="9" name="Card 126"/>
+          <p:cNvPr id="9" name="Card 112"/>
           <p:cNvSpPr/>
           <p:nvPr/>
         </p:nvSpPr>
@@ -4450,7 +4450,7 @@
       </p:sp>
       <p:sp>
         <p:nvSpPr>
-          <p:cNvPr id="10" name="Dot 127"/>
+          <p:cNvPr id="10" name="Dot 113"/>
           <p:cNvSpPr/>
           <p:nvPr/>
         </p:nvSpPr>
@@ -4475,7 +4475,7 @@
       </p:sp>
       <p:sp>
         <p:nvSpPr>
-          <p:cNvPr id="11" name="Text 128"/>
+          <p:cNvPr id="11" name="Text 114"/>
           <p:cNvSpPr txBox="1"/>
           <p:nvPr/>
         </p:nvSpPr>
@@ -4514,7 +4514,7 @@
       </p:sp>
       <p:sp>
         <p:nvSpPr>
-          <p:cNvPr id="12" name="Text 129"/>
+          <p:cNvPr id="12" name="Text 115"/>
           <p:cNvSpPr txBox="1"/>
           <p:nvPr/>
         </p:nvSpPr>
@@ -4553,7 +4553,7 @@
       </p:sp>
       <p:sp>
         <p:nvSpPr>
-          <p:cNvPr id="13" name="Card 130"/>
+          <p:cNvPr id="13" name="Card 116"/>
           <p:cNvSpPr/>
           <p:nvPr/>
         </p:nvSpPr>
@@ -4587,7 +4587,7 @@
       </p:sp>
       <p:sp>
         <p:nvSpPr>
-          <p:cNvPr id="14" name="Dot 131"/>
+          <p:cNvPr id="14" name="Dot 117"/>
           <p:cNvSpPr/>
           <p:nvPr/>
         </p:nvSpPr>
@@ -4612,7 +4612,7 @@
       </p:sp>
       <p:sp>
         <p:nvSpPr>
-          <p:cNvPr id="15" name="Text 132"/>
+          <p:cNvPr id="15" name="Text 118"/>
           <p:cNvSpPr txBox="1"/>
           <p:nvPr/>
         </p:nvSpPr>
@@ -4651,7 +4651,7 @@
       </p:sp>
       <p:sp>
         <p:nvSpPr>
-          <p:cNvPr id="16" name="Text 133"/>
+          <p:cNvPr id="16" name="Text 119"/>
           <p:cNvSpPr txBox="1"/>
           <p:nvPr/>
         </p:nvSpPr>
@@ -4690,7 +4690,7 @@
       </p:sp>
       <p:sp>
         <p:nvSpPr>
-          <p:cNvPr id="17" name="Text 134"/>
+          <p:cNvPr id="17" name="Text 120"/>
           <p:cNvSpPr txBox="1"/>
           <p:nvPr/>
         </p:nvSpPr>
@@ -4754,7 +4754,7 @@
       </p:grpSpPr>
       <p:sp>
         <p:nvSpPr>
-          <p:cNvPr id="2" name="Accent 135"/>
+          <p:cNvPr id="2" name="Accent 121"/>
           <p:cNvSpPr/>
           <p:nvPr/>
         </p:nvSpPr>
@@ -4779,7 +4779,7 @@
       </p:sp>
       <p:sp>
         <p:nvSpPr>
-          <p:cNvPr id="3" name="Text 136"/>
+          <p:cNvPr id="3" name="Text 122"/>
           <p:cNvSpPr txBox="1"/>
           <p:nvPr/>
         </p:nvSpPr>
@@ -4818,7 +4818,7 @@
       </p:sp>
       <p:sp>
         <p:nvSpPr>
-          <p:cNvPr id="4" name="Tag 137"/>
+          <p:cNvPr id="4" name="Tag 123"/>
           <p:cNvSpPr/>
           <p:nvPr/>
         </p:nvSpPr>
@@ -4845,7 +4845,7 @@
       </p:sp>
       <p:sp>
         <p:nvSpPr>
-          <p:cNvPr id="5" name="Text 138"/>
+          <p:cNvPr id="5" name="Text 124"/>
           <p:cNvSpPr txBox="1"/>
           <p:nvPr/>
         </p:nvSpPr>
@@ -4884,7 +4884,7 @@
       </p:sp>
       <p:sp>
         <p:nvSpPr>
-          <p:cNvPr id="6" name="Card 139"/>
+          <p:cNvPr id="6" name="Card 125"/>
           <p:cNvSpPr/>
           <p:nvPr/>
         </p:nvSpPr>
@@ -4913,7 +4913,7 @@
       </p:sp>
       <p:sp>
         <p:nvSpPr>
-          <p:cNvPr id="7" name="Dot 140"/>
+          <p:cNvPr id="7" name="Dot 126"/>
           <p:cNvSpPr/>
           <p:nvPr/>
         </p:nvSpPr>
@@ -4938,7 +4938,7 @@
       </p:sp>
       <p:sp>
         <p:nvSpPr>
-          <p:cNvPr id="8" name="Text 141"/>
+          <p:cNvPr id="8" name="Text 127"/>
           <p:cNvSpPr txBox="1"/>
           <p:nvPr/>
         </p:nvSpPr>
@@ -4977,7 +4977,7 @@
       </p:sp>
       <p:sp>
         <p:nvSpPr>
-          <p:cNvPr id="9" name="Text 142"/>
+          <p:cNvPr id="9" name="Text 128"/>
           <p:cNvSpPr txBox="1"/>
           <p:nvPr/>
         </p:nvSpPr>
@@ -5016,7 +5016,7 @@
       </p:sp>
       <p:sp>
         <p:nvSpPr>
-          <p:cNvPr id="10" name="Card 143"/>
+          <p:cNvPr id="10" name="Card 129"/>
           <p:cNvSpPr/>
           <p:nvPr/>
         </p:nvSpPr>
@@ -5045,7 +5045,7 @@
       </p:sp>
       <p:sp>
         <p:nvSpPr>
-          <p:cNvPr id="11" name="Dot 144"/>
+          <p:cNvPr id="11" name="Dot 130"/>
           <p:cNvSpPr/>
           <p:nvPr/>
         </p:nvSpPr>
@@ -5070,7 +5070,7 @@
       </p:sp>
       <p:sp>
         <p:nvSpPr>
-          <p:cNvPr id="12" name="Text 145"/>
+          <p:cNvPr id="12" name="Text 131"/>
           <p:cNvSpPr txBox="1"/>
           <p:nvPr/>
         </p:nvSpPr>
@@ -5109,7 +5109,7 @@
       </p:sp>
       <p:sp>
         <p:nvSpPr>
-          <p:cNvPr id="13" name="Text 146"/>
+          <p:cNvPr id="13" name="Text 132"/>
           <p:cNvSpPr txBox="1"/>
           <p:nvPr/>
         </p:nvSpPr>
@@ -5148,7 +5148,7 @@
       </p:sp>
       <p:sp>
         <p:nvSpPr>
-          <p:cNvPr id="14" name="Card 147"/>
+          <p:cNvPr id="14" name="Card 133"/>
           <p:cNvSpPr/>
           <p:nvPr/>
         </p:nvSpPr>
@@ -5177,7 +5177,7 @@
       </p:sp>
       <p:sp>
         <p:nvSpPr>
-          <p:cNvPr id="15" name="Dot 148"/>
+          <p:cNvPr id="15" name="Dot 134"/>
           <p:cNvSpPr/>
           <p:nvPr/>
         </p:nvSpPr>
@@ -5202,7 +5202,7 @@
       </p:sp>
       <p:sp>
         <p:nvSpPr>
-          <p:cNvPr id="16" name="Text 149"/>
+          <p:cNvPr id="16" name="Text 135"/>
           <p:cNvSpPr txBox="1"/>
           <p:nvPr/>
         </p:nvSpPr>
@@ -5241,7 +5241,7 @@
       </p:sp>
       <p:sp>
         <p:nvSpPr>
-          <p:cNvPr id="17" name="Text 150"/>
+          <p:cNvPr id="17" name="Text 136"/>
           <p:cNvSpPr txBox="1"/>
           <p:nvPr/>
         </p:nvSpPr>
@@ -5280,7 +5280,7 @@
       </p:sp>
       <p:sp>
         <p:nvSpPr>
-          <p:cNvPr id="18" name="Card 151"/>
+          <p:cNvPr id="18" name="Card 137"/>
           <p:cNvSpPr/>
           <p:nvPr/>
         </p:nvSpPr>
@@ -5309,7 +5309,7 @@
       </p:sp>
       <p:sp>
         <p:nvSpPr>
-          <p:cNvPr id="19" name="Dot 152"/>
+          <p:cNvPr id="19" name="Dot 138"/>
           <p:cNvSpPr/>
           <p:nvPr/>
         </p:nvSpPr>
@@ -5334,7 +5334,7 @@
       </p:sp>
       <p:sp>
         <p:nvSpPr>
-          <p:cNvPr id="20" name="Text 153"/>
+          <p:cNvPr id="20" name="Text 139"/>
           <p:cNvSpPr txBox="1"/>
           <p:nvPr/>
         </p:nvSpPr>
@@ -5373,7 +5373,7 @@
       </p:sp>
       <p:sp>
         <p:nvSpPr>
-          <p:cNvPr id="21" name="Text 154"/>
+          <p:cNvPr id="21" name="Text 140"/>
           <p:cNvSpPr txBox="1"/>
           <p:nvPr/>
         </p:nvSpPr>
@@ -5412,7 +5412,7 @@
       </p:sp>
       <p:sp>
         <p:nvSpPr>
-          <p:cNvPr id="22" name="Card 155"/>
+          <p:cNvPr id="22" name="Card 141"/>
           <p:cNvSpPr/>
           <p:nvPr/>
         </p:nvSpPr>
@@ -5441,7 +5441,7 @@
       </p:sp>
       <p:pic>
         <p:nvPicPr>
-          <p:cNvPr id="23" name="Picture 156" descr="Activity picture">    </p:cNvPr>
+          <p:cNvPr id="23" name="Picture 142" descr="Activity picture">    </p:cNvPr>
           <p:cNvPicPr>
             <a:picLocks noChangeAspect="1"/>
           </p:cNvPicPr>
@@ -5490,7 +5490,7 @@
       </p:grpSpPr>
       <p:sp>
         <p:nvSpPr>
-          <p:cNvPr id="2" name="Accent 157"/>
+          <p:cNvPr id="2" name="Accent 143"/>
           <p:cNvSpPr/>
           <p:nvPr/>
         </p:nvSpPr>
@@ -5515,7 +5515,7 @@
       </p:sp>
       <p:sp>
         <p:nvSpPr>
-          <p:cNvPr id="3" name="Text 158"/>
+          <p:cNvPr id="3" name="Text 144"/>
           <p:cNvSpPr txBox="1"/>
           <p:nvPr/>
         </p:nvSpPr>
@@ -5554,7 +5554,7 @@
       </p:sp>
       <p:sp>
         <p:nvSpPr>
-          <p:cNvPr id="4" name="Card 159"/>
+          <p:cNvPr id="4" name="Card 145"/>
           <p:cNvSpPr/>
           <p:nvPr/>
         </p:nvSpPr>
@@ -5583,7 +5583,7 @@
       </p:sp>
       <p:sp>
         <p:nvSpPr>
-          <p:cNvPr id="5" name="Text 160"/>
+          <p:cNvPr id="5" name="Text 146"/>
           <p:cNvSpPr txBox="1"/>
           <p:nvPr/>
         </p:nvSpPr>
@@ -5624,7 +5624,7 @@
       </p:sp>
       <p:sp>
         <p:nvSpPr>
-          <p:cNvPr id="6" name="Text 161"/>
+          <p:cNvPr id="6" name="Text 147"/>
           <p:cNvSpPr txBox="1"/>
           <p:nvPr/>
         </p:nvSpPr>
@@ -5663,7 +5663,7 @@
       </p:sp>
       <p:sp>
         <p:nvSpPr>
-          <p:cNvPr id="7" name="Text 162"/>
+          <p:cNvPr id="7" name="Text 148"/>
           <p:cNvSpPr txBox="1"/>
           <p:nvPr/>
         </p:nvSpPr>
@@ -5753,7 +5753,7 @@
       </p:sp>
       <p:sp>
         <p:nvSpPr>
-          <p:cNvPr id="8" name="Card 163"/>
+          <p:cNvPr id="8" name="Card 149"/>
           <p:cNvSpPr/>
           <p:nvPr/>
         </p:nvSpPr>
@@ -5782,7 +5782,7 @@
       </p:sp>
       <p:pic>
         <p:nvPicPr>
-          <p:cNvPr id="9" name="Picture 164" descr="Help questions">    </p:cNvPr>
+          <p:cNvPr id="9" name="Picture 150" descr="Help questions">    </p:cNvPr>
           <p:cNvPicPr>
             <a:picLocks noChangeAspect="1"/>
           </p:cNvPicPr>
@@ -5831,7 +5831,7 @@
       </p:grpSpPr>
       <p:sp>
         <p:nvSpPr>
-          <p:cNvPr id="2" name="Text 165"/>
+          <p:cNvPr id="2" name="Text 151"/>
           <p:cNvSpPr txBox="1"/>
           <p:nvPr/>
         </p:nvSpPr>
@@ -5870,7 +5870,7 @@
       </p:sp>
       <p:sp>
         <p:nvSpPr>
-          <p:cNvPr id="3" name="Text 166"/>
+          <p:cNvPr id="3" name="Text 152"/>
           <p:cNvSpPr txBox="1"/>
           <p:nvPr/>
         </p:nvSpPr>
@@ -5909,7 +5909,7 @@
       </p:sp>
       <p:pic>
         <p:nvPicPr>
-          <p:cNvPr id="4" name="Icon 167" descr="FaFolder">    </p:cNvPr>
+          <p:cNvPr id="4" name="Icon 153" descr="FaFolder">    </p:cNvPr>
           <p:cNvPicPr>
             <a:picLocks noChangeAspect="1"/>
           </p:cNvPicPr>
@@ -5933,7 +5933,7 @@
       </p:pic>
       <p:pic>
         <p:nvPicPr>
-          <p:cNvPr id="5" name="Icon 168" descr="FaDownload">    </p:cNvPr>
+          <p:cNvPr id="5" name="Icon 154" descr="FaDownload">    </p:cNvPr>
           <p:cNvPicPr>
             <a:picLocks noChangeAspect="1"/>
           </p:cNvPicPr>
@@ -5957,7 +5957,7 @@
       </p:pic>
       <p:pic>
         <p:nvPicPr>
-          <p:cNvPr id="6" name="Icon 169" descr="FaSave">    </p:cNvPr>
+          <p:cNvPr id="6" name="Icon 155" descr="FaSave">    </p:cNvPr>
           <p:cNvPicPr>
             <a:picLocks noChangeAspect="1"/>
           </p:cNvPicPr>
@@ -5981,7 +5981,7 @@
       </p:pic>
       <p:pic>
         <p:nvPicPr>
-          <p:cNvPr id="7" name="Icon 170" descr="FaStar">    </p:cNvPr>
+          <p:cNvPr id="7" name="Icon 156" descr="FaStar">    </p:cNvPr>
           <p:cNvPicPr>
             <a:picLocks noChangeAspect="1"/>
           </p:cNvPicPr>
@@ -6910,271 +6910,9 @@
           </a:p>
         </p:txBody>
       </p:sp>
-      <p:sp>
-        <p:nvSpPr>
-          <p:cNvPr id="4" name="Card 27"/>
-          <p:cNvSpPr/>
-          <p:nvPr/>
-        </p:nvSpPr>
-        <p:spPr>
-          <a:xfrm>
-            <a:off x="457200" y="1143000"/>
-            <a:ext cx="3931920" cy="777240"/>
-          </a:xfrm>
-          <a:prstGeom prst="roundRect">
-            <a:avLst>
-              <a:gd name="adj" fmla="val 14118"/>
-            </a:avLst>
-          </a:prstGeom>
-          <a:solidFill>
-            <a:srgbClr val="4DA3E0"/>
-          </a:solidFill>
-          <a:ln/>
-          <a:effectLst>
-            <a:outerShdw sx="100000" sy="100000" kx="0" ky="0" algn="bl" rotWithShape="0" blurRad="76200" dist="25400" dir="5400000">
-              <a:srgbClr val="2B2250">
-                <a:alpha val="15000"/>
-              </a:srgbClr>
-            </a:outerShdw>
-          </a:effectLst>
-        </p:spPr>
-      </p:sp>
-      <p:sp>
-        <p:nvSpPr>
-          <p:cNvPr id="5" name="Text 28"/>
-          <p:cNvSpPr txBox="1"/>
-          <p:nvPr/>
-        </p:nvSpPr>
-        <p:spPr>
-          <a:xfrm>
-            <a:off x="457200" y="1143000"/>
-            <a:ext cx="3931920" cy="777240"/>
-          </a:xfrm>
-          <a:prstGeom prst="rect">
-            <a:avLst/>
-          </a:prstGeom>
-          <a:noFill/>
-          <a:ln/>
-        </p:spPr>
-        <p:txBody>
-          <a:bodyPr wrap="square" lIns="0" tIns="0" rIns="0" bIns="0" rtlCol="0" anchor="ctr">
-            <a:normAutofit/>
-          </a:bodyPr>
-          <a:lstStyle/>
-          <a:p>
-            <a:pPr algn="ctr" indent="0" marL="0">
-              <a:buNone/>
-            </a:pPr>
-            <a:r>
-              <a:rPr lang="en-US" sz="3400" b="1" dirty="0">
-                <a:solidFill>
-                  <a:srgbClr val="FFFFFF"/>
-                </a:solidFill>
-                <a:latin typeface="Calibri" pitchFamily="34" charset="0"/>
-                <a:ea typeface="Calibri" pitchFamily="34" charset="-122"/>
-                <a:cs typeface="Calibri" pitchFamily="34" charset="-120"/>
-              </a:rPr>
-              <a:t>DOCUMENTS</a:t>
-            </a:r>
-            <a:endParaRPr lang="en-US" sz="3400" dirty="0"/>
-          </a:p>
-        </p:txBody>
-      </p:sp>
-      <p:sp>
-        <p:nvSpPr>
-          <p:cNvPr id="6" name="Text 29"/>
-          <p:cNvSpPr txBox="1"/>
-          <p:nvPr/>
-        </p:nvSpPr>
-        <p:spPr>
-          <a:xfrm>
-            <a:off x="457200" y="2011680"/>
-            <a:ext cx="3931920" cy="685800"/>
-          </a:xfrm>
-          <a:prstGeom prst="rect">
-            <a:avLst/>
-          </a:prstGeom>
-          <a:noFill/>
-          <a:ln/>
-        </p:spPr>
-        <p:txBody>
-          <a:bodyPr wrap="square" lIns="0" tIns="0" rIns="0" bIns="0" rtlCol="0" anchor="ctr"/>
-          <a:lstStyle/>
-          <a:p>
-            <a:pPr indent="0" marL="0">
-              <a:buNone/>
-            </a:pPr>
-            <a:r>
-              <a:rPr lang="en-US" sz="2000" b="1" i="1" dirty="0">
-                <a:solidFill>
-                  <a:srgbClr val="4DA3E0"/>
-                </a:solidFill>
-                <a:latin typeface="Calibri" pitchFamily="34" charset="0"/>
-                <a:ea typeface="Calibri" pitchFamily="34" charset="-122"/>
-                <a:cs typeface="Calibri" pitchFamily="34" charset="-120"/>
-              </a:rPr>
-              <a:t>The big home for all your folders</a:t>
-            </a:r>
-            <a:endParaRPr lang="en-US" sz="2000" dirty="0"/>
-          </a:p>
-        </p:txBody>
-      </p:sp>
-      <p:sp>
-        <p:nvSpPr>
-          <p:cNvPr id="7" name="Text 30"/>
-          <p:cNvSpPr txBox="1"/>
-          <p:nvPr/>
-        </p:nvSpPr>
-        <p:spPr>
-          <a:xfrm>
-            <a:off x="457200" y="2743200"/>
-            <a:ext cx="3931920" cy="2194560"/>
-          </a:xfrm>
-          <a:prstGeom prst="rect">
-            <a:avLst/>
-          </a:prstGeom>
-          <a:noFill/>
-          <a:ln/>
-        </p:spPr>
-        <p:txBody>
-          <a:bodyPr wrap="square" lIns="0" tIns="0" rIns="0" bIns="0" rtlCol="0" anchor="t"/>
-          <a:lstStyle/>
-          <a:p>
-            <a:pPr indent="0" marL="0">
-              <a:buNone/>
-            </a:pPr>
-            <a:r>
-              <a:rPr lang="en-US" sz="1800" b="1" dirty="0">
-                <a:solidFill>
-                  <a:srgbClr val="4DA3E0"/>
-                </a:solidFill>
-                <a:latin typeface="Calibri" pitchFamily="34" charset="0"/>
-                <a:ea typeface="Calibri" pitchFamily="34" charset="-122"/>
-                <a:cs typeface="Calibri" pitchFamily="34" charset="-120"/>
-              </a:rPr>
-              <a:t>Click: </a:t>
-            </a:r>
-            <a:pPr indent="0" marL="0">
-              <a:spcAft>
-                <a:spcPts val="1000"/>
-              </a:spcAft>
-              <a:buNone/>
-            </a:pPr>
-            <a:r>
-              <a:rPr lang="en-US" sz="1800" dirty="0">
-                <a:solidFill>
-                  <a:schemeClr val="tx1"/>
-                </a:solidFill>
-                <a:latin typeface="Calibri" pitchFamily="34" charset="0"/>
-                <a:ea typeface="Calibri" pitchFamily="34" charset="-122"/>
-                <a:cs typeface="Calibri" pitchFamily="34" charset="-120"/>
-              </a:rPr>
-              <a:t>the yellow folder on the taskbar.</a:t>
-            </a:r>
-            <a:endParaRPr lang="en-US" sz="1800" dirty="0"/>
-          </a:p>
-          <a:p>
-            <a:pPr indent="0" marL="0">
-              <a:buNone/>
-            </a:pPr>
-            <a:r>
-              <a:rPr lang="en-US" sz="1800" b="1" dirty="0">
-                <a:solidFill>
-                  <a:srgbClr val="4DA3E0"/>
-                </a:solidFill>
-                <a:latin typeface="Calibri" pitchFamily="34" charset="0"/>
-                <a:ea typeface="Calibri" pitchFamily="34" charset="-122"/>
-                <a:cs typeface="Calibri" pitchFamily="34" charset="-120"/>
-              </a:rPr>
-              <a:t>Then click: </a:t>
-            </a:r>
-            <a:pPr indent="0" marL="0">
-              <a:spcAft>
-                <a:spcPts val="1000"/>
-              </a:spcAft>
-              <a:buNone/>
-            </a:pPr>
-            <a:r>
-              <a:rPr lang="en-US" sz="1800" dirty="0">
-                <a:solidFill>
-                  <a:schemeClr val="tx1"/>
-                </a:solidFill>
-                <a:latin typeface="Calibri" pitchFamily="34" charset="0"/>
-                <a:ea typeface="Calibri" pitchFamily="34" charset="-122"/>
-                <a:cs typeface="Calibri" pitchFamily="34" charset="-120"/>
-              </a:rPr>
-              <a:t>Documents on the left.</a:t>
-            </a:r>
-            <a:endParaRPr lang="en-US" sz="1800" dirty="0"/>
-          </a:p>
-          <a:p>
-            <a:pPr indent="0" marL="0">
-              <a:buNone/>
-            </a:pPr>
-            <a:r>
-              <a:rPr lang="en-US" sz="1800" b="1" dirty="0">
-                <a:solidFill>
-                  <a:srgbClr val="4DA3E0"/>
-                </a:solidFill>
-                <a:latin typeface="Calibri" pitchFamily="34" charset="0"/>
-                <a:ea typeface="Calibri" pitchFamily="34" charset="-122"/>
-                <a:cs typeface="Calibri" pitchFamily="34" charset="-120"/>
-              </a:rPr>
-              <a:t>Documents: </a:t>
-            </a:r>
-            <a:pPr indent="0" marL="0">
-              <a:spcAft>
-                <a:spcPts val="1000"/>
-              </a:spcAft>
-              <a:buNone/>
-            </a:pPr>
-            <a:r>
-              <a:rPr lang="en-US" sz="1800" dirty="0">
-                <a:solidFill>
-                  <a:schemeClr val="tx1"/>
-                </a:solidFill>
-                <a:latin typeface="Calibri" pitchFamily="34" charset="0"/>
-                <a:ea typeface="Calibri" pitchFamily="34" charset="-122"/>
-                <a:cs typeface="Calibri" pitchFamily="34" charset="-120"/>
-              </a:rPr>
-              <a:t>is where we keep our own work.</a:t>
-            </a:r>
-            <a:endParaRPr lang="en-US" sz="1800" dirty="0"/>
-          </a:p>
-        </p:txBody>
-      </p:sp>
-      <p:sp>
-        <p:nvSpPr>
-          <p:cNvPr id="8" name="Card 31"/>
-          <p:cNvSpPr/>
-          <p:nvPr/>
-        </p:nvSpPr>
-        <p:spPr>
-          <a:xfrm>
-            <a:off x="4434840" y="1097280"/>
-            <a:ext cx="4389120" cy="3127248"/>
-          </a:xfrm>
-          <a:prstGeom prst="roundRect">
-            <a:avLst>
-              <a:gd name="adj" fmla="val 3509"/>
-            </a:avLst>
-          </a:prstGeom>
-          <a:solidFill>
-            <a:srgbClr val="FFFFFF"/>
-          </a:solidFill>
-          <a:ln/>
-          <a:effectLst>
-            <a:outerShdw sx="100000" sy="100000" kx="0" ky="0" algn="bl" rotWithShape="0" blurRad="76200" dist="25400" dir="5400000">
-              <a:srgbClr val="2B2250">
-                <a:alpha val="15000"/>
-              </a:srgbClr>
-            </a:outerShdw>
-          </a:effectLst>
-        </p:spPr>
-      </p:sp>
       <p:pic>
         <p:nvPicPr>
-          <p:cNvPr id="9" name="Picture 32" descr="File Explorer with Documents highlighted">    </p:cNvPr>
+          <p:cNvPr id="4" name="Image 0" descr="/tmp/claude-0/-home-claude/14c3e32a-71e8-510d-8ed6-ad99b5ed7597/scratchpad/shots/w1.png">    </p:cNvPr>
           <p:cNvPicPr>
             <a:picLocks noChangeAspect="1"/>
           </p:cNvPicPr>
@@ -7188,14 +6926,180 @@
         </p:blipFill>
         <p:spPr>
           <a:xfrm>
-            <a:off x="4526280" y="1188720"/>
-            <a:ext cx="4206240" cy="2944368"/>
+            <a:off x="640080" y="1097280"/>
+            <a:ext cx="6751930" cy="3246120"/>
           </a:xfrm>
           <a:prstGeom prst="rect">
             <a:avLst/>
           </a:prstGeom>
         </p:spPr>
       </p:pic>
+      <p:sp>
+        <p:nvSpPr>
+          <p:cNvPr id="5" name="Shape 2"/>
+          <p:cNvSpPr/>
+          <p:nvPr/>
+        </p:nvSpPr>
+        <p:spPr>
+          <a:xfrm>
+            <a:off x="640080" y="1097280"/>
+            <a:ext cx="6751930" cy="3246120"/>
+          </a:xfrm>
+          <a:prstGeom prst="rect">
+            <a:avLst/>
+          </a:prstGeom>
+          <a:ln w="12700">
+            <a:solidFill>
+              <a:srgbClr val="B9B3D6"/>
+            </a:solidFill>
+            <a:prstDash val="solid"/>
+          </a:ln>
+        </p:spPr>
+      </p:sp>
+      <p:sp>
+        <p:nvSpPr>
+          <p:cNvPr id="6" name="Shape 3"/>
+          <p:cNvSpPr/>
+          <p:nvPr/>
+        </p:nvSpPr>
+        <p:spPr>
+          <a:xfrm>
+            <a:off x="649877" y="2451898"/>
+            <a:ext cx="1751860" cy="249370"/>
+          </a:xfrm>
+          <a:prstGeom prst="roundRect">
+            <a:avLst>
+              <a:gd name="adj" fmla="val 22001"/>
+            </a:avLst>
+          </a:prstGeom>
+          <a:ln w="44450">
+            <a:solidFill>
+              <a:srgbClr val="FF5C8A"/>
+            </a:solidFill>
+            <a:prstDash val="solid"/>
+          </a:ln>
+        </p:spPr>
+      </p:sp>
+      <p:sp>
+        <p:nvSpPr>
+          <p:cNvPr id="7" name="Shape 4"/>
+          <p:cNvSpPr/>
+          <p:nvPr/>
+        </p:nvSpPr>
+        <p:spPr>
+          <a:xfrm>
+            <a:off x="503573" y="2305594"/>
+            <a:ext cx="347472" cy="347472"/>
+          </a:xfrm>
+          <a:prstGeom prst="ellipse">
+            <a:avLst/>
+          </a:prstGeom>
+          <a:solidFill>
+            <a:srgbClr val="FF5C8A"/>
+          </a:solidFill>
+          <a:ln w="19050">
+            <a:solidFill>
+              <a:srgbClr val="FFFFFF"/>
+            </a:solidFill>
+            <a:prstDash val="solid"/>
+          </a:ln>
+        </p:spPr>
+      </p:sp>
+      <p:sp>
+        <p:nvSpPr>
+          <p:cNvPr id="8" name="Text 27"/>
+          <p:cNvSpPr txBox="1"/>
+          <p:nvPr/>
+        </p:nvSpPr>
+        <p:spPr>
+          <a:xfrm>
+            <a:off x="503573" y="2305594"/>
+            <a:ext cx="347472" cy="347472"/>
+          </a:xfrm>
+          <a:prstGeom prst="rect">
+            <a:avLst/>
+          </a:prstGeom>
+          <a:noFill/>
+          <a:ln/>
+        </p:spPr>
+        <p:txBody>
+          <a:bodyPr wrap="square" lIns="0" tIns="0" rIns="0" bIns="0" rtlCol="0" anchor="ctr"/>
+          <a:lstStyle/>
+          <a:p>
+            <a:pPr algn="ctr" indent="0" marL="0">
+              <a:buNone/>
+            </a:pPr>
+            <a:r>
+              <a:rPr lang="en-US" sz="1600" b="1" dirty="0">
+                <a:solidFill>
+                  <a:srgbClr val="FFFFFF"/>
+                </a:solidFill>
+                <a:latin typeface="Calibri" pitchFamily="34" charset="0"/>
+                <a:ea typeface="Calibri" pitchFamily="34" charset="-122"/>
+                <a:cs typeface="Calibri" pitchFamily="34" charset="-120"/>
+              </a:rPr>
+              <a:t>1</a:t>
+            </a:r>
+            <a:endParaRPr lang="en-US" sz="1600" dirty="0"/>
+          </a:p>
+        </p:txBody>
+      </p:sp>
+      <p:sp>
+        <p:nvSpPr>
+          <p:cNvPr id="9" name="Text 28"/>
+          <p:cNvSpPr txBox="1"/>
+          <p:nvPr/>
+        </p:nvSpPr>
+        <p:spPr>
+          <a:xfrm>
+            <a:off x="640080" y="4434840"/>
+            <a:ext cx="7863840" cy="548640"/>
+          </a:xfrm>
+          <a:prstGeom prst="rect">
+            <a:avLst/>
+          </a:prstGeom>
+          <a:noFill/>
+          <a:ln/>
+        </p:spPr>
+        <p:txBody>
+          <a:bodyPr wrap="square" lIns="0" tIns="0" rIns="0" bIns="0" rtlCol="0" anchor="t"/>
+          <a:lstStyle/>
+          <a:p>
+            <a:pPr indent="0" marL="0">
+              <a:buNone/>
+            </a:pPr>
+            <a:r>
+              <a:rPr lang="en-US" sz="2000" b="1" dirty="0">
+                <a:solidFill>
+                  <a:srgbClr val="4DA3E0"/>
+                </a:solidFill>
+                <a:latin typeface="Calibri" pitchFamily="34" charset="0"/>
+                <a:ea typeface="Calibri" pitchFamily="34" charset="-122"/>
+                <a:cs typeface="Calibri" pitchFamily="34" charset="-120"/>
+              </a:rPr>
+              <a:t>1 </a:t>
+            </a:r>
+            <a:pPr indent="0" marL="0">
+              <a:spcAft>
+                <a:spcPts val="800"/>
+              </a:spcAft>
+              <a:buNone/>
+            </a:pPr>
+            <a:r>
+              <a:rPr lang="en-US" sz="2000" dirty="0">
+                <a:solidFill>
+                  <a:schemeClr val="tx1"/>
+                </a:solidFill>
+                <a:latin typeface="Calibri" pitchFamily="34" charset="0"/>
+                <a:ea typeface="Calibri" pitchFamily="34" charset="-122"/>
+                <a:cs typeface="Calibri" pitchFamily="34" charset="-120"/>
+              </a:rPr>
+              <a:t>Click Documents on the left. Your own folders will be inside.</a:t>
+            </a:r>
+            <a:endParaRPr lang="en-US" sz="1800" dirty="0"/>
+          </a:p>
+        </p:txBody>
+      </p:sp>
     </p:spTree>
   </p:cSld>
   <p:clrMapOvr>
@@ -7223,7 +7127,7 @@
       </p:grpSpPr>
       <p:sp>
         <p:nvSpPr>
-          <p:cNvPr id="2" name="Accent 33"/>
+          <p:cNvPr id="2" name="Accent 29"/>
           <p:cNvSpPr/>
           <p:nvPr/>
         </p:nvSpPr>
@@ -7248,7 +7152,7 @@
       </p:sp>
       <p:sp>
         <p:nvSpPr>
-          <p:cNvPr id="3" name="Text 34"/>
+          <p:cNvPr id="3" name="Text 30"/>
           <p:cNvSpPr txBox="1"/>
           <p:nvPr/>
         </p:nvSpPr>
@@ -7285,305 +7189,9 @@
           </a:p>
         </p:txBody>
       </p:sp>
-      <p:sp>
-        <p:nvSpPr>
-          <p:cNvPr id="4" name="Card 35"/>
-          <p:cNvSpPr/>
-          <p:nvPr/>
-        </p:nvSpPr>
-        <p:spPr>
-          <a:xfrm>
-            <a:off x="457200" y="1143000"/>
-            <a:ext cx="3931920" cy="777240"/>
-          </a:xfrm>
-          <a:prstGeom prst="roundRect">
-            <a:avLst>
-              <a:gd name="adj" fmla="val 14118"/>
-            </a:avLst>
-          </a:prstGeom>
-          <a:solidFill>
-            <a:srgbClr val="1FB89A"/>
-          </a:solidFill>
-          <a:ln/>
-          <a:effectLst>
-            <a:outerShdw sx="100000" sy="100000" kx="0" ky="0" algn="bl" rotWithShape="0" blurRad="76200" dist="25400" dir="5400000">
-              <a:srgbClr val="2B2250">
-                <a:alpha val="15000"/>
-              </a:srgbClr>
-            </a:outerShdw>
-          </a:effectLst>
-        </p:spPr>
-      </p:sp>
-      <p:sp>
-        <p:nvSpPr>
-          <p:cNvPr id="5" name="Text 36"/>
-          <p:cNvSpPr txBox="1"/>
-          <p:nvPr/>
-        </p:nvSpPr>
-        <p:spPr>
-          <a:xfrm>
-            <a:off x="457200" y="1143000"/>
-            <a:ext cx="3931920" cy="777240"/>
-          </a:xfrm>
-          <a:prstGeom prst="rect">
-            <a:avLst/>
-          </a:prstGeom>
-          <a:noFill/>
-          <a:ln/>
-        </p:spPr>
-        <p:txBody>
-          <a:bodyPr wrap="square" lIns="0" tIns="0" rIns="0" bIns="0" rtlCol="0" anchor="ctr">
-            <a:normAutofit/>
-          </a:bodyPr>
-          <a:lstStyle/>
-          <a:p>
-            <a:pPr algn="ctr" indent="0" marL="0">
-              <a:buNone/>
-            </a:pPr>
-            <a:r>
-              <a:rPr lang="en-US" sz="3400" b="1" dirty="0">
-                <a:solidFill>
-                  <a:srgbClr val="FFFFFF"/>
-                </a:solidFill>
-                <a:latin typeface="Calibri" pitchFamily="34" charset="0"/>
-                <a:ea typeface="Calibri" pitchFamily="34" charset="-122"/>
-                <a:cs typeface="Calibri" pitchFamily="34" charset="-120"/>
-              </a:rPr>
-              <a:t>NEW FOLDER</a:t>
-            </a:r>
-            <a:endParaRPr lang="en-US" sz="3400" dirty="0"/>
-          </a:p>
-        </p:txBody>
-      </p:sp>
-      <p:sp>
-        <p:nvSpPr>
-          <p:cNvPr id="6" name="Text 37"/>
-          <p:cNvSpPr txBox="1"/>
-          <p:nvPr/>
-        </p:nvSpPr>
-        <p:spPr>
-          <a:xfrm>
-            <a:off x="457200" y="2011680"/>
-            <a:ext cx="3931920" cy="685800"/>
-          </a:xfrm>
-          <a:prstGeom prst="rect">
-            <a:avLst/>
-          </a:prstGeom>
-          <a:noFill/>
-          <a:ln/>
-        </p:spPr>
-        <p:txBody>
-          <a:bodyPr wrap="square" lIns="0" tIns="0" rIns="0" bIns="0" rtlCol="0" anchor="ctr"/>
-          <a:lstStyle/>
-          <a:p>
-            <a:pPr indent="0" marL="0">
-              <a:buNone/>
-            </a:pPr>
-            <a:r>
-              <a:rPr lang="en-US" sz="2000" b="1" i="1" dirty="0">
-                <a:solidFill>
-                  <a:srgbClr val="1FB89A"/>
-                </a:solidFill>
-                <a:latin typeface="Calibri" pitchFamily="34" charset="0"/>
-                <a:ea typeface="Calibri" pitchFamily="34" charset="-122"/>
-                <a:cs typeface="Calibri" pitchFamily="34" charset="-120"/>
-              </a:rPr>
-              <a:t>Right-click, New, Folder</a:t>
-            </a:r>
-            <a:endParaRPr lang="en-US" sz="2000" dirty="0"/>
-          </a:p>
-        </p:txBody>
-      </p:sp>
-      <p:sp>
-        <p:nvSpPr>
-          <p:cNvPr id="7" name="Text 38"/>
-          <p:cNvSpPr txBox="1"/>
-          <p:nvPr/>
-        </p:nvSpPr>
-        <p:spPr>
-          <a:xfrm>
-            <a:off x="457200" y="2743200"/>
-            <a:ext cx="3931920" cy="2194560"/>
-          </a:xfrm>
-          <a:prstGeom prst="rect">
-            <a:avLst/>
-          </a:prstGeom>
-          <a:noFill/>
-          <a:ln/>
-        </p:spPr>
-        <p:txBody>
-          <a:bodyPr wrap="square" lIns="0" tIns="0" rIns="0" bIns="0" rtlCol="0" anchor="t"/>
-          <a:lstStyle/>
-          <a:p>
-            <a:pPr indent="0" marL="0">
-              <a:buNone/>
-            </a:pPr>
-            <a:r>
-              <a:rPr lang="en-US" sz="1800" b="1" dirty="0">
-                <a:solidFill>
-                  <a:srgbClr val="1FB89A"/>
-                </a:solidFill>
-                <a:latin typeface="Calibri" pitchFamily="34" charset="0"/>
-                <a:ea typeface="Calibri" pitchFamily="34" charset="-122"/>
-                <a:cs typeface="Calibri" pitchFamily="34" charset="-120"/>
-              </a:rPr>
-              <a:t>Right-click: </a:t>
-            </a:r>
-            <a:pPr indent="0" marL="0">
-              <a:spcAft>
-                <a:spcPts val="1000"/>
-              </a:spcAft>
-              <a:buNone/>
-            </a:pPr>
-            <a:r>
-              <a:rPr lang="en-US" sz="1800" dirty="0">
-                <a:solidFill>
-                  <a:schemeClr val="tx1"/>
-                </a:solidFill>
-                <a:latin typeface="Calibri" pitchFamily="34" charset="0"/>
-                <a:ea typeface="Calibri" pitchFamily="34" charset="-122"/>
-                <a:cs typeface="Calibri" pitchFamily="34" charset="-120"/>
-              </a:rPr>
-              <a:t>on the empty white space.</a:t>
-            </a:r>
-            <a:endParaRPr lang="en-US" sz="1800" dirty="0"/>
-          </a:p>
-          <a:p>
-            <a:pPr indent="0" marL="0">
-              <a:buNone/>
-            </a:pPr>
-            <a:r>
-              <a:rPr lang="en-US" sz="1800" b="1" dirty="0">
-                <a:solidFill>
-                  <a:srgbClr val="1FB89A"/>
-                </a:solidFill>
-                <a:latin typeface="Calibri" pitchFamily="34" charset="0"/>
-                <a:ea typeface="Calibri" pitchFamily="34" charset="-122"/>
-                <a:cs typeface="Calibri" pitchFamily="34" charset="-120"/>
-              </a:rPr>
-              <a:t>Click: </a:t>
-            </a:r>
-            <a:pPr indent="0" marL="0">
-              <a:spcAft>
-                <a:spcPts val="1000"/>
-              </a:spcAft>
-              <a:buNone/>
-            </a:pPr>
-            <a:r>
-              <a:rPr lang="en-US" sz="1800" dirty="0">
-                <a:solidFill>
-                  <a:schemeClr val="tx1"/>
-                </a:solidFill>
-                <a:latin typeface="Calibri" pitchFamily="34" charset="0"/>
-                <a:ea typeface="Calibri" pitchFamily="34" charset="-122"/>
-                <a:cs typeface="Calibri" pitchFamily="34" charset="-120"/>
-              </a:rPr>
-              <a:t>New, then Folder.</a:t>
-            </a:r>
-            <a:endParaRPr lang="en-US" sz="1800" dirty="0"/>
-          </a:p>
-          <a:p>
-            <a:pPr indent="0" marL="0">
-              <a:buNone/>
-            </a:pPr>
-            <a:r>
-              <a:rPr lang="en-US" sz="1800" b="1" dirty="0">
-                <a:solidFill>
-                  <a:srgbClr val="1FB89A"/>
-                </a:solidFill>
-                <a:latin typeface="Calibri" pitchFamily="34" charset="0"/>
-                <a:ea typeface="Calibri" pitchFamily="34" charset="-122"/>
-                <a:cs typeface="Calibri" pitchFamily="34" charset="-120"/>
-              </a:rPr>
-              <a:t>Type: </a:t>
-            </a:r>
-            <a:pPr indent="0" marL="0">
-              <a:spcAft>
-                <a:spcPts val="1000"/>
-              </a:spcAft>
-              <a:buNone/>
-            </a:pPr>
-            <a:r>
-              <a:rPr lang="en-US" sz="1800" dirty="0">
-                <a:solidFill>
-                  <a:schemeClr val="tx1"/>
-                </a:solidFill>
-                <a:latin typeface="Calibri" pitchFamily="34" charset="0"/>
-                <a:ea typeface="Calibri" pitchFamily="34" charset="-122"/>
-                <a:cs typeface="Calibri" pitchFamily="34" charset="-120"/>
-              </a:rPr>
-              <a:t>Y3-Ali (class + your name).</a:t>
-            </a:r>
-            <a:endParaRPr lang="en-US" sz="1800" dirty="0"/>
-          </a:p>
-          <a:p>
-            <a:pPr indent="0" marL="0">
-              <a:buNone/>
-            </a:pPr>
-            <a:r>
-              <a:rPr lang="en-US" sz="1800" b="1" dirty="0">
-                <a:solidFill>
-                  <a:srgbClr val="1FB89A"/>
-                </a:solidFill>
-                <a:latin typeface="Calibri" pitchFamily="34" charset="0"/>
-                <a:ea typeface="Calibri" pitchFamily="34" charset="-122"/>
-                <a:cs typeface="Calibri" pitchFamily="34" charset="-120"/>
-              </a:rPr>
-              <a:t>Press: </a:t>
-            </a:r>
-            <a:pPr indent="0" marL="0">
-              <a:spcAft>
-                <a:spcPts val="1000"/>
-              </a:spcAft>
-              <a:buNone/>
-            </a:pPr>
-            <a:r>
-              <a:rPr lang="en-US" sz="1800" dirty="0">
-                <a:solidFill>
-                  <a:schemeClr val="tx1"/>
-                </a:solidFill>
-                <a:latin typeface="Calibri" pitchFamily="34" charset="0"/>
-                <a:ea typeface="Calibri" pitchFamily="34" charset="-122"/>
-                <a:cs typeface="Calibri" pitchFamily="34" charset="-120"/>
-              </a:rPr>
-              <a:t>Enter.</a:t>
-            </a:r>
-            <a:endParaRPr lang="en-US" sz="1800" dirty="0"/>
-          </a:p>
-        </p:txBody>
-      </p:sp>
-      <p:sp>
-        <p:nvSpPr>
-          <p:cNvPr id="8" name="Card 39"/>
-          <p:cNvSpPr/>
-          <p:nvPr/>
-        </p:nvSpPr>
-        <p:spPr>
-          <a:xfrm>
-            <a:off x="4434840" y="1097280"/>
-            <a:ext cx="4389120" cy="3127248"/>
-          </a:xfrm>
-          <a:prstGeom prst="roundRect">
-            <a:avLst>
-              <a:gd name="adj" fmla="val 3509"/>
-            </a:avLst>
-          </a:prstGeom>
-          <a:solidFill>
-            <a:srgbClr val="FFFFFF"/>
-          </a:solidFill>
-          <a:ln/>
-          <a:effectLst>
-            <a:outerShdw sx="100000" sy="100000" kx="0" ky="0" algn="bl" rotWithShape="0" blurRad="76200" dist="25400" dir="5400000">
-              <a:srgbClr val="2B2250">
-                <a:alpha val="15000"/>
-              </a:srgbClr>
-            </a:outerShdw>
-          </a:effectLst>
-        </p:spPr>
-      </p:sp>
       <p:pic>
         <p:nvPicPr>
-          <p:cNvPr id="9" name="Picture 40" descr="Right-click menu and new folder named Y3-Ali">    </p:cNvPr>
+          <p:cNvPr id="4" name="Image 0" descr="/tmp/claude-0/-home-claude/14c3e32a-71e8-510d-8ed6-ad99b5ed7597/scratchpad/shots/w2.png">    </p:cNvPr>
           <p:cNvPicPr>
             <a:picLocks noChangeAspect="1"/>
           </p:cNvPicPr>
@@ -7597,14 +7205,248 @@
         </p:blipFill>
         <p:spPr>
           <a:xfrm>
-            <a:off x="4526280" y="1188720"/>
-            <a:ext cx="4206240" cy="2944368"/>
+            <a:off x="548640" y="1188720"/>
+            <a:ext cx="8046720" cy="1356189"/>
           </a:xfrm>
           <a:prstGeom prst="rect">
             <a:avLst/>
           </a:prstGeom>
         </p:spPr>
       </p:pic>
+      <p:sp>
+        <p:nvSpPr>
+          <p:cNvPr id="5" name="Shape 2"/>
+          <p:cNvSpPr/>
+          <p:nvPr/>
+        </p:nvSpPr>
+        <p:spPr>
+          <a:xfrm>
+            <a:off x="548640" y="1188720"/>
+            <a:ext cx="8046720" cy="1356189"/>
+          </a:xfrm>
+          <a:prstGeom prst="rect">
+            <a:avLst/>
+          </a:prstGeom>
+          <a:ln w="12700">
+            <a:solidFill>
+              <a:srgbClr val="B9B3D6"/>
+            </a:solidFill>
+            <a:prstDash val="solid"/>
+          </a:ln>
+        </p:spPr>
+      </p:sp>
+      <p:sp>
+        <p:nvSpPr>
+          <p:cNvPr id="6" name="Shape 3"/>
+          <p:cNvSpPr/>
+          <p:nvPr/>
+        </p:nvSpPr>
+        <p:spPr>
+          <a:xfrm>
+            <a:off x="625080" y="1717223"/>
+            <a:ext cx="1225912" cy="615628"/>
+          </a:xfrm>
+          <a:prstGeom prst="roundRect">
+            <a:avLst>
+              <a:gd name="adj" fmla="val 8912"/>
+            </a:avLst>
+          </a:prstGeom>
+          <a:ln w="44450">
+            <a:solidFill>
+              <a:srgbClr val="FF5C8A"/>
+            </a:solidFill>
+            <a:prstDash val="solid"/>
+          </a:ln>
+        </p:spPr>
+      </p:sp>
+      <p:sp>
+        <p:nvSpPr>
+          <p:cNvPr id="7" name="Shape 4"/>
+          <p:cNvSpPr/>
+          <p:nvPr/>
+        </p:nvSpPr>
+        <p:spPr>
+          <a:xfrm>
+            <a:off x="478776" y="1570919"/>
+            <a:ext cx="347472" cy="347472"/>
+          </a:xfrm>
+          <a:prstGeom prst="ellipse">
+            <a:avLst/>
+          </a:prstGeom>
+          <a:solidFill>
+            <a:srgbClr val="FF5C8A"/>
+          </a:solidFill>
+          <a:ln w="19050">
+            <a:solidFill>
+              <a:srgbClr val="FFFFFF"/>
+            </a:solidFill>
+            <a:prstDash val="solid"/>
+          </a:ln>
+        </p:spPr>
+      </p:sp>
+      <p:sp>
+        <p:nvSpPr>
+          <p:cNvPr id="8" name="Text 31"/>
+          <p:cNvSpPr txBox="1"/>
+          <p:nvPr/>
+        </p:nvSpPr>
+        <p:spPr>
+          <a:xfrm>
+            <a:off x="478776" y="1570919"/>
+            <a:ext cx="347472" cy="347472"/>
+          </a:xfrm>
+          <a:prstGeom prst="rect">
+            <a:avLst/>
+          </a:prstGeom>
+          <a:noFill/>
+          <a:ln/>
+        </p:spPr>
+        <p:txBody>
+          <a:bodyPr wrap="square" lIns="0" tIns="0" rIns="0" bIns="0" rtlCol="0" anchor="ctr"/>
+          <a:lstStyle/>
+          <a:p>
+            <a:pPr algn="ctr" indent="0" marL="0">
+              <a:buNone/>
+            </a:pPr>
+            <a:r>
+              <a:rPr lang="en-US" sz="1600" b="1" dirty="0">
+                <a:solidFill>
+                  <a:srgbClr val="FFFFFF"/>
+                </a:solidFill>
+                <a:latin typeface="Calibri" pitchFamily="34" charset="0"/>
+                <a:ea typeface="Calibri" pitchFamily="34" charset="-122"/>
+                <a:cs typeface="Calibri" pitchFamily="34" charset="-120"/>
+              </a:rPr>
+              <a:t>1</a:t>
+            </a:r>
+            <a:endParaRPr lang="en-US" sz="1600" dirty="0"/>
+          </a:p>
+        </p:txBody>
+      </p:sp>
+      <p:sp>
+        <p:nvSpPr>
+          <p:cNvPr id="9" name="Text 32"/>
+          <p:cNvSpPr txBox="1"/>
+          <p:nvPr/>
+        </p:nvSpPr>
+        <p:spPr>
+          <a:xfrm>
+            <a:off x="640080" y="2743200"/>
+            <a:ext cx="7863840" cy="2011680"/>
+          </a:xfrm>
+          <a:prstGeom prst="rect">
+            <a:avLst/>
+          </a:prstGeom>
+          <a:noFill/>
+          <a:ln/>
+        </p:spPr>
+        <p:txBody>
+          <a:bodyPr wrap="square" lIns="0" tIns="0" rIns="0" bIns="0" rtlCol="0" anchor="t"/>
+          <a:lstStyle/>
+          <a:p>
+            <a:pPr indent="0" marL="0">
+              <a:buNone/>
+            </a:pPr>
+            <a:r>
+              <a:rPr lang="en-US" sz="2000" b="1" dirty="0">
+                <a:solidFill>
+                  <a:srgbClr val="1FB89A"/>
+                </a:solidFill>
+                <a:latin typeface="Calibri" pitchFamily="34" charset="0"/>
+                <a:ea typeface="Calibri" pitchFamily="34" charset="-122"/>
+                <a:cs typeface="Calibri" pitchFamily="34" charset="-120"/>
+              </a:rPr>
+              <a:t>1 </a:t>
+            </a:r>
+            <a:pPr indent="0" marL="0">
+              <a:spcAft>
+                <a:spcPts val="800"/>
+              </a:spcAft>
+              <a:buNone/>
+            </a:pPr>
+            <a:r>
+              <a:rPr lang="en-US" sz="2000" dirty="0">
+                <a:solidFill>
+                  <a:schemeClr val="tx1"/>
+                </a:solidFill>
+                <a:latin typeface="Calibri" pitchFamily="34" charset="0"/>
+                <a:ea typeface="Calibri" pitchFamily="34" charset="-122"/>
+                <a:cs typeface="Calibri" pitchFamily="34" charset="-120"/>
+              </a:rPr>
+              <a:t>Click New (top left).</a:t>
+            </a:r>
+            <a:endParaRPr lang="en-US" sz="1800" dirty="0"/>
+          </a:p>
+          <a:p>
+            <a:pPr indent="0" marL="0">
+              <a:buNone/>
+            </a:pPr>
+            <a:r>
+              <a:rPr lang="en-US" sz="2000" b="1" dirty="0">
+                <a:solidFill>
+                  <a:srgbClr val="1FB89A"/>
+                </a:solidFill>
+                <a:latin typeface="Calibri" pitchFamily="34" charset="0"/>
+                <a:ea typeface="Calibri" pitchFamily="34" charset="-122"/>
+                <a:cs typeface="Calibri" pitchFamily="34" charset="-120"/>
+              </a:rPr>
+              <a:t>2 </a:t>
+            </a:r>
+            <a:pPr indent="0" marL="0">
+              <a:spcAft>
+                <a:spcPts val="800"/>
+              </a:spcAft>
+              <a:buNone/>
+            </a:pPr>
+            <a:r>
+              <a:rPr lang="en-US" sz="2000" dirty="0">
+                <a:solidFill>
+                  <a:schemeClr val="tx1"/>
+                </a:solidFill>
+                <a:latin typeface="Calibri" pitchFamily="34" charset="0"/>
+                <a:ea typeface="Calibri" pitchFamily="34" charset="-122"/>
+                <a:cs typeface="Calibri" pitchFamily="34" charset="-120"/>
+              </a:rPr>
+              <a:t>Click Folder.</a:t>
+            </a:r>
+            <a:endParaRPr lang="en-US" sz="1800" dirty="0"/>
+          </a:p>
+          <a:p>
+            <a:pPr indent="0" marL="0">
+              <a:buNone/>
+            </a:pPr>
+            <a:r>
+              <a:rPr lang="en-US" sz="2000" b="1" dirty="0">
+                <a:solidFill>
+                  <a:srgbClr val="1FB89A"/>
+                </a:solidFill>
+                <a:latin typeface="Calibri" pitchFamily="34" charset="0"/>
+                <a:ea typeface="Calibri" pitchFamily="34" charset="-122"/>
+                <a:cs typeface="Calibri" pitchFamily="34" charset="-120"/>
+              </a:rPr>
+              <a:t>3 </a:t>
+            </a:r>
+            <a:pPr indent="0" marL="0">
+              <a:spcAft>
+                <a:spcPts val="800"/>
+              </a:spcAft>
+              <a:buNone/>
+            </a:pPr>
+            <a:r>
+              <a:rPr lang="en-US" sz="2000" dirty="0">
+                <a:solidFill>
+                  <a:schemeClr val="tx1"/>
+                </a:solidFill>
+                <a:latin typeface="Calibri" pitchFamily="34" charset="0"/>
+                <a:ea typeface="Calibri" pitchFamily="34" charset="-122"/>
+                <a:cs typeface="Calibri" pitchFamily="34" charset="-120"/>
+              </a:rPr>
+              <a:t>Type Y3-Ali (class + your name), press Enter.</a:t>
+            </a:r>
+            <a:endParaRPr lang="en-US" sz="1800" dirty="0"/>
+          </a:p>
+        </p:txBody>
+      </p:sp>
     </p:spTree>
   </p:cSld>
   <p:clrMapOvr>
@@ -7632,7 +7474,7 @@
       </p:grpSpPr>
       <p:sp>
         <p:nvSpPr>
-          <p:cNvPr id="2" name="Accent 41"/>
+          <p:cNvPr id="2" name="Accent 33"/>
           <p:cNvSpPr/>
           <p:nvPr/>
         </p:nvSpPr>
@@ -7657,7 +7499,7 @@
       </p:sp>
       <p:sp>
         <p:nvSpPr>
-          <p:cNvPr id="3" name="Text 42"/>
+          <p:cNvPr id="3" name="Text 34"/>
           <p:cNvSpPr txBox="1"/>
           <p:nvPr/>
         </p:nvSpPr>
@@ -7694,271 +7536,9 @@
           </a:p>
         </p:txBody>
       </p:sp>
-      <p:sp>
-        <p:nvSpPr>
-          <p:cNvPr id="4" name="Card 43"/>
-          <p:cNvSpPr/>
-          <p:nvPr/>
-        </p:nvSpPr>
-        <p:spPr>
-          <a:xfrm>
-            <a:off x="457200" y="1143000"/>
-            <a:ext cx="3931920" cy="777240"/>
-          </a:xfrm>
-          <a:prstGeom prst="roundRect">
-            <a:avLst>
-              <a:gd name="adj" fmla="val 14118"/>
-            </a:avLst>
-          </a:prstGeom>
-          <a:solidFill>
-            <a:srgbClr val="FF9A3D"/>
-          </a:solidFill>
-          <a:ln/>
-          <a:effectLst>
-            <a:outerShdw sx="100000" sy="100000" kx="0" ky="0" algn="bl" rotWithShape="0" blurRad="76200" dist="25400" dir="5400000">
-              <a:srgbClr val="2B2250">
-                <a:alpha val="15000"/>
-              </a:srgbClr>
-            </a:outerShdw>
-          </a:effectLst>
-        </p:spPr>
-      </p:sp>
-      <p:sp>
-        <p:nvSpPr>
-          <p:cNvPr id="5" name="Text 44"/>
-          <p:cNvSpPr txBox="1"/>
-          <p:nvPr/>
-        </p:nvSpPr>
-        <p:spPr>
-          <a:xfrm>
-            <a:off x="457200" y="1143000"/>
-            <a:ext cx="3931920" cy="777240"/>
-          </a:xfrm>
-          <a:prstGeom prst="rect">
-            <a:avLst/>
-          </a:prstGeom>
-          <a:noFill/>
-          <a:ln/>
-        </p:spPr>
-        <p:txBody>
-          <a:bodyPr wrap="square" lIns="0" tIns="0" rIns="0" bIns="0" rtlCol="0" anchor="ctr">
-            <a:normAutofit/>
-          </a:bodyPr>
-          <a:lstStyle/>
-          <a:p>
-            <a:pPr algn="ctr" indent="0" marL="0">
-              <a:buNone/>
-            </a:pPr>
-            <a:r>
-              <a:rPr lang="en-US" sz="3400" b="1" dirty="0">
-                <a:solidFill>
-                  <a:srgbClr val="FFFFFF"/>
-                </a:solidFill>
-                <a:latin typeface="Calibri" pitchFamily="34" charset="0"/>
-                <a:ea typeface="Calibri" pitchFamily="34" charset="-122"/>
-                <a:cs typeface="Calibri" pitchFamily="34" charset="-120"/>
-              </a:rPr>
-              <a:t>DOWNLOAD</a:t>
-            </a:r>
-            <a:endParaRPr lang="en-US" sz="3400" dirty="0"/>
-          </a:p>
-        </p:txBody>
-      </p:sp>
-      <p:sp>
-        <p:nvSpPr>
-          <p:cNvPr id="6" name="Text 45"/>
-          <p:cNvSpPr txBox="1"/>
-          <p:nvPr/>
-        </p:nvSpPr>
-        <p:spPr>
-          <a:xfrm>
-            <a:off x="457200" y="2011680"/>
-            <a:ext cx="3931920" cy="685800"/>
-          </a:xfrm>
-          <a:prstGeom prst="rect">
-            <a:avLst/>
-          </a:prstGeom>
-          <a:noFill/>
-          <a:ln/>
-        </p:spPr>
-        <p:txBody>
-          <a:bodyPr wrap="square" lIns="0" tIns="0" rIns="0" bIns="0" rtlCol="0" anchor="ctr"/>
-          <a:lstStyle/>
-          <a:p>
-            <a:pPr indent="0" marL="0">
-              <a:buNone/>
-            </a:pPr>
-            <a:r>
-              <a:rPr lang="en-US" sz="2000" b="1" i="1" dirty="0">
-                <a:solidFill>
-                  <a:srgbClr val="FF9A3D"/>
-                </a:solidFill>
-                <a:latin typeface="Calibri" pitchFamily="34" charset="0"/>
-                <a:ea typeface="Calibri" pitchFamily="34" charset="-122"/>
-                <a:cs typeface="Calibri" pitchFamily="34" charset="-120"/>
-              </a:rPr>
-              <a:t>Get the file from the Work Area</a:t>
-            </a:r>
-            <a:endParaRPr lang="en-US" sz="2000" dirty="0"/>
-          </a:p>
-        </p:txBody>
-      </p:sp>
-      <p:sp>
-        <p:nvSpPr>
-          <p:cNvPr id="7" name="Text 46"/>
-          <p:cNvSpPr txBox="1"/>
-          <p:nvPr/>
-        </p:nvSpPr>
-        <p:spPr>
-          <a:xfrm>
-            <a:off x="457200" y="2743200"/>
-            <a:ext cx="3931920" cy="2194560"/>
-          </a:xfrm>
-          <a:prstGeom prst="rect">
-            <a:avLst/>
-          </a:prstGeom>
-          <a:noFill/>
-          <a:ln/>
-        </p:spPr>
-        <p:txBody>
-          <a:bodyPr wrap="square" lIns="0" tIns="0" rIns="0" bIns="0" rtlCol="0" anchor="t"/>
-          <a:lstStyle/>
-          <a:p>
-            <a:pPr indent="0" marL="0">
-              <a:buNone/>
-            </a:pPr>
-            <a:r>
-              <a:rPr lang="en-US" sz="1800" b="1" dirty="0">
-                <a:solidFill>
-                  <a:srgbClr val="FF9A3D"/>
-                </a:solidFill>
-                <a:latin typeface="Calibri" pitchFamily="34" charset="0"/>
-                <a:ea typeface="Calibri" pitchFamily="34" charset="-122"/>
-                <a:cs typeface="Calibri" pitchFamily="34" charset="-120"/>
-              </a:rPr>
-              <a:t>Go to: </a:t>
-            </a:r>
-            <a:pPr indent="0" marL="0">
-              <a:spcAft>
-                <a:spcPts val="1000"/>
-              </a:spcAft>
-              <a:buNone/>
-            </a:pPr>
-            <a:r>
-              <a:rPr lang="en-US" sz="1800" dirty="0">
-                <a:solidFill>
-                  <a:schemeClr val="tx1"/>
-                </a:solidFill>
-                <a:latin typeface="Calibri" pitchFamily="34" charset="0"/>
-                <a:ea typeface="Calibri" pitchFamily="34" charset="-122"/>
-                <a:cs typeface="Calibri" pitchFamily="34" charset="-120"/>
-              </a:rPr>
-              <a:t>your class Work Area page.</a:t>
-            </a:r>
-            <a:endParaRPr lang="en-US" sz="1800" dirty="0"/>
-          </a:p>
-          <a:p>
-            <a:pPr indent="0" marL="0">
-              <a:buNone/>
-            </a:pPr>
-            <a:r>
-              <a:rPr lang="en-US" sz="1800" b="1" dirty="0">
-                <a:solidFill>
-                  <a:srgbClr val="FF9A3D"/>
-                </a:solidFill>
-                <a:latin typeface="Calibri" pitchFamily="34" charset="0"/>
-                <a:ea typeface="Calibri" pitchFamily="34" charset="-122"/>
-                <a:cs typeface="Calibri" pitchFamily="34" charset="-120"/>
-              </a:rPr>
-              <a:t>Find: </a:t>
-            </a:r>
-            <a:pPr indent="0" marL="0">
-              <a:spcAft>
-                <a:spcPts val="1000"/>
-              </a:spcAft>
-              <a:buNone/>
-            </a:pPr>
-            <a:r>
-              <a:rPr lang="en-US" sz="1800" dirty="0">
-                <a:solidFill>
-                  <a:schemeClr val="tx1"/>
-                </a:solidFill>
-                <a:latin typeface="Calibri" pitchFamily="34" charset="0"/>
-                <a:ea typeface="Calibri" pitchFamily="34" charset="-122"/>
-                <a:cs typeface="Calibri" pitchFamily="34" charset="-120"/>
-              </a:rPr>
-              <a:t>your task file.</a:t>
-            </a:r>
-            <a:endParaRPr lang="en-US" sz="1800" dirty="0"/>
-          </a:p>
-          <a:p>
-            <a:pPr indent="0" marL="0">
-              <a:buNone/>
-            </a:pPr>
-            <a:r>
-              <a:rPr lang="en-US" sz="1800" b="1" dirty="0">
-                <a:solidFill>
-                  <a:srgbClr val="FF9A3D"/>
-                </a:solidFill>
-                <a:latin typeface="Calibri" pitchFamily="34" charset="0"/>
-                <a:ea typeface="Calibri" pitchFamily="34" charset="-122"/>
-                <a:cs typeface="Calibri" pitchFamily="34" charset="-120"/>
-              </a:rPr>
-              <a:t>Press: </a:t>
-            </a:r>
-            <a:pPr indent="0" marL="0">
-              <a:spcAft>
-                <a:spcPts val="1000"/>
-              </a:spcAft>
-              <a:buNone/>
-            </a:pPr>
-            <a:r>
-              <a:rPr lang="en-US" sz="1800" dirty="0">
-                <a:solidFill>
-                  <a:schemeClr val="tx1"/>
-                </a:solidFill>
-                <a:latin typeface="Calibri" pitchFamily="34" charset="0"/>
-                <a:ea typeface="Calibri" pitchFamily="34" charset="-122"/>
-                <a:cs typeface="Calibri" pitchFamily="34" charset="-120"/>
-              </a:rPr>
-              <a:t>the orange Download button.</a:t>
-            </a:r>
-            <a:endParaRPr lang="en-US" sz="1800" dirty="0"/>
-          </a:p>
-        </p:txBody>
-      </p:sp>
-      <p:sp>
-        <p:nvSpPr>
-          <p:cNvPr id="8" name="Card 47"/>
-          <p:cNvSpPr/>
-          <p:nvPr/>
-        </p:nvSpPr>
-        <p:spPr>
-          <a:xfrm>
-            <a:off x="4434840" y="1097280"/>
-            <a:ext cx="4389120" cy="3127248"/>
-          </a:xfrm>
-          <a:prstGeom prst="roundRect">
-            <a:avLst>
-              <a:gd name="adj" fmla="val 3509"/>
-            </a:avLst>
-          </a:prstGeom>
-          <a:solidFill>
-            <a:srgbClr val="FFFFFF"/>
-          </a:solidFill>
-          <a:ln/>
-          <a:effectLst>
-            <a:outerShdw sx="100000" sy="100000" kx="0" ky="0" algn="bl" rotWithShape="0" blurRad="76200" dist="25400" dir="5400000">
-              <a:srgbClr val="2B2250">
-                <a:alpha val="15000"/>
-              </a:srgbClr>
-            </a:outerShdw>
-          </a:effectLst>
-        </p:spPr>
-      </p:sp>
       <p:pic>
         <p:nvPicPr>
-          <p:cNvPr id="9" name="Picture 48" descr="Download button on the Work Area page">    </p:cNvPr>
+          <p:cNvPr id="4" name="Image 0" descr="/tmp/claude-0/-home-claude/14c3e32a-71e8-510d-8ed6-ad99b5ed7597/scratchpad/shots/w3.png">    </p:cNvPr>
           <p:cNvPicPr>
             <a:picLocks noChangeAspect="1"/>
           </p:cNvPicPr>
@@ -7972,14 +7552,180 @@
         </p:blipFill>
         <p:spPr>
           <a:xfrm>
-            <a:off x="4526280" y="1188720"/>
-            <a:ext cx="4206240" cy="2944368"/>
+            <a:off x="822960" y="1143000"/>
+            <a:ext cx="7498080" cy="2852928"/>
           </a:xfrm>
           <a:prstGeom prst="rect">
             <a:avLst/>
           </a:prstGeom>
         </p:spPr>
       </p:pic>
+      <p:sp>
+        <p:nvSpPr>
+          <p:cNvPr id="5" name="Shape 2"/>
+          <p:cNvSpPr/>
+          <p:nvPr/>
+        </p:nvSpPr>
+        <p:spPr>
+          <a:xfrm>
+            <a:off x="822960" y="1143000"/>
+            <a:ext cx="7498080" cy="2852928"/>
+          </a:xfrm>
+          <a:prstGeom prst="rect">
+            <a:avLst/>
+          </a:prstGeom>
+          <a:ln w="12700">
+            <a:solidFill>
+              <a:srgbClr val="B9B3D6"/>
+            </a:solidFill>
+            <a:prstDash val="solid"/>
+          </a:ln>
+        </p:spPr>
+      </p:sp>
+      <p:sp>
+        <p:nvSpPr>
+          <p:cNvPr id="6" name="Shape 3"/>
+          <p:cNvSpPr/>
+          <p:nvPr/>
+        </p:nvSpPr>
+        <p:spPr>
+          <a:xfrm>
+            <a:off x="6748272" y="3026664"/>
+            <a:ext cx="1444752" cy="530352"/>
+          </a:xfrm>
+          <a:prstGeom prst="roundRect">
+            <a:avLst>
+              <a:gd name="adj" fmla="val 10345"/>
+            </a:avLst>
+          </a:prstGeom>
+          <a:ln w="44450">
+            <a:solidFill>
+              <a:srgbClr val="FF5C8A"/>
+            </a:solidFill>
+            <a:prstDash val="solid"/>
+          </a:ln>
+        </p:spPr>
+      </p:sp>
+      <p:sp>
+        <p:nvSpPr>
+          <p:cNvPr id="7" name="Shape 4"/>
+          <p:cNvSpPr/>
+          <p:nvPr/>
+        </p:nvSpPr>
+        <p:spPr>
+          <a:xfrm>
+            <a:off x="6601968" y="2880360"/>
+            <a:ext cx="347472" cy="347472"/>
+          </a:xfrm>
+          <a:prstGeom prst="ellipse">
+            <a:avLst/>
+          </a:prstGeom>
+          <a:solidFill>
+            <a:srgbClr val="FF5C8A"/>
+          </a:solidFill>
+          <a:ln w="19050">
+            <a:solidFill>
+              <a:srgbClr val="FFFFFF"/>
+            </a:solidFill>
+            <a:prstDash val="solid"/>
+          </a:ln>
+        </p:spPr>
+      </p:sp>
+      <p:sp>
+        <p:nvSpPr>
+          <p:cNvPr id="8" name="Text 35"/>
+          <p:cNvSpPr txBox="1"/>
+          <p:nvPr/>
+        </p:nvSpPr>
+        <p:spPr>
+          <a:xfrm>
+            <a:off x="6601968" y="2880360"/>
+            <a:ext cx="347472" cy="347472"/>
+          </a:xfrm>
+          <a:prstGeom prst="rect">
+            <a:avLst/>
+          </a:prstGeom>
+          <a:noFill/>
+          <a:ln/>
+        </p:spPr>
+        <p:txBody>
+          <a:bodyPr wrap="square" lIns="0" tIns="0" rIns="0" bIns="0" rtlCol="0" anchor="ctr"/>
+          <a:lstStyle/>
+          <a:p>
+            <a:pPr algn="ctr" indent="0" marL="0">
+              <a:buNone/>
+            </a:pPr>
+            <a:r>
+              <a:rPr lang="en-US" sz="1600" b="1" dirty="0">
+                <a:solidFill>
+                  <a:srgbClr val="FFFFFF"/>
+                </a:solidFill>
+                <a:latin typeface="Calibri" pitchFamily="34" charset="0"/>
+                <a:ea typeface="Calibri" pitchFamily="34" charset="-122"/>
+                <a:cs typeface="Calibri" pitchFamily="34" charset="-120"/>
+              </a:rPr>
+              <a:t>1</a:t>
+            </a:r>
+            <a:endParaRPr lang="en-US" sz="1600" dirty="0"/>
+          </a:p>
+        </p:txBody>
+      </p:sp>
+      <p:sp>
+        <p:nvSpPr>
+          <p:cNvPr id="9" name="Text 36"/>
+          <p:cNvSpPr txBox="1"/>
+          <p:nvPr/>
+        </p:nvSpPr>
+        <p:spPr>
+          <a:xfrm>
+            <a:off x="640080" y="4343400"/>
+            <a:ext cx="7863840" cy="640080"/>
+          </a:xfrm>
+          <a:prstGeom prst="rect">
+            <a:avLst/>
+          </a:prstGeom>
+          <a:noFill/>
+          <a:ln/>
+        </p:spPr>
+        <p:txBody>
+          <a:bodyPr wrap="square" lIns="0" tIns="0" rIns="0" bIns="0" rtlCol="0" anchor="t"/>
+          <a:lstStyle/>
+          <a:p>
+            <a:pPr indent="0" marL="0">
+              <a:buNone/>
+            </a:pPr>
+            <a:r>
+              <a:rPr lang="en-US" sz="2000" b="1" dirty="0">
+                <a:solidFill>
+                  <a:srgbClr val="FF9A3D"/>
+                </a:solidFill>
+                <a:latin typeface="Calibri" pitchFamily="34" charset="0"/>
+                <a:ea typeface="Calibri" pitchFamily="34" charset="-122"/>
+                <a:cs typeface="Calibri" pitchFamily="34" charset="-120"/>
+              </a:rPr>
+              <a:t>1 </a:t>
+            </a:r>
+            <a:pPr indent="0" marL="0">
+              <a:spcAft>
+                <a:spcPts val="800"/>
+              </a:spcAft>
+              <a:buNone/>
+            </a:pPr>
+            <a:r>
+              <a:rPr lang="en-US" sz="2000" dirty="0">
+                <a:solidFill>
+                  <a:schemeClr val="tx1"/>
+                </a:solidFill>
+                <a:latin typeface="Calibri" pitchFamily="34" charset="0"/>
+                <a:ea typeface="Calibri" pitchFamily="34" charset="-122"/>
+                <a:cs typeface="Calibri" pitchFamily="34" charset="-120"/>
+              </a:rPr>
+              <a:t>Press the Download button next to your file.</a:t>
+            </a:r>
+            <a:endParaRPr lang="en-US" sz="1800" dirty="0"/>
+          </a:p>
+        </p:txBody>
+      </p:sp>
     </p:spTree>
   </p:cSld>
   <p:clrMapOvr>
@@ -8007,7 +7753,7 @@
       </p:grpSpPr>
       <p:sp>
         <p:nvSpPr>
-          <p:cNvPr id="2" name="Accent 49"/>
+          <p:cNvPr id="2" name="Accent 37"/>
           <p:cNvSpPr/>
           <p:nvPr/>
         </p:nvSpPr>
@@ -8032,7 +7778,7 @@
       </p:sp>
       <p:sp>
         <p:nvSpPr>
-          <p:cNvPr id="3" name="Text 50"/>
+          <p:cNvPr id="3" name="Text 38"/>
           <p:cNvSpPr txBox="1"/>
           <p:nvPr/>
         </p:nvSpPr>
@@ -8063,277 +7809,15 @@
                 <a:ea typeface="Calibri" pitchFamily="34" charset="-122"/>
                 <a:cs typeface="Calibri" pitchFamily="34" charset="-120"/>
               </a:rPr>
-              <a:t>Step 4: Choose where to save</a:t>
+              <a:t>Step 4: Save in YOUR folder</a:t>
             </a:r>
             <a:endParaRPr lang="en-US" sz="3000" dirty="0"/>
           </a:p>
         </p:txBody>
-      </p:sp>
-      <p:sp>
-        <p:nvSpPr>
-          <p:cNvPr id="4" name="Card 51"/>
-          <p:cNvSpPr/>
-          <p:nvPr/>
-        </p:nvSpPr>
-        <p:spPr>
-          <a:xfrm>
-            <a:off x="457200" y="1143000"/>
-            <a:ext cx="3931920" cy="777240"/>
-          </a:xfrm>
-          <a:prstGeom prst="roundRect">
-            <a:avLst>
-              <a:gd name="adj" fmla="val 14118"/>
-            </a:avLst>
-          </a:prstGeom>
-          <a:solidFill>
-            <a:srgbClr val="6C63FF"/>
-          </a:solidFill>
-          <a:ln/>
-          <a:effectLst>
-            <a:outerShdw sx="100000" sy="100000" kx="0" ky="0" algn="bl" rotWithShape="0" blurRad="76200" dist="25400" dir="5400000">
-              <a:srgbClr val="2B2250">
-                <a:alpha val="15000"/>
-              </a:srgbClr>
-            </a:outerShdw>
-          </a:effectLst>
-        </p:spPr>
-      </p:sp>
-      <p:sp>
-        <p:nvSpPr>
-          <p:cNvPr id="5" name="Text 52"/>
-          <p:cNvSpPr txBox="1"/>
-          <p:nvPr/>
-        </p:nvSpPr>
-        <p:spPr>
-          <a:xfrm>
-            <a:off x="457200" y="1143000"/>
-            <a:ext cx="3931920" cy="777240"/>
-          </a:xfrm>
-          <a:prstGeom prst="rect">
-            <a:avLst/>
-          </a:prstGeom>
-          <a:noFill/>
-          <a:ln/>
-        </p:spPr>
-        <p:txBody>
-          <a:bodyPr wrap="square" lIns="0" tIns="0" rIns="0" bIns="0" rtlCol="0" anchor="ctr">
-            <a:normAutofit/>
-          </a:bodyPr>
-          <a:lstStyle/>
-          <a:p>
-            <a:pPr algn="ctr" indent="0" marL="0">
-              <a:buNone/>
-            </a:pPr>
-            <a:r>
-              <a:rPr lang="en-US" sz="3400" b="1" dirty="0">
-                <a:solidFill>
-                  <a:srgbClr val="FFFFFF"/>
-                </a:solidFill>
-                <a:latin typeface="Calibri" pitchFamily="34" charset="0"/>
-                <a:ea typeface="Calibri" pitchFamily="34" charset="-122"/>
-                <a:cs typeface="Calibri" pitchFamily="34" charset="-120"/>
-              </a:rPr>
-              <a:t>SAVE AS</a:t>
-            </a:r>
-            <a:endParaRPr lang="en-US" sz="3400" dirty="0"/>
-          </a:p>
-        </p:txBody>
-      </p:sp>
-      <p:sp>
-        <p:nvSpPr>
-          <p:cNvPr id="6" name="Text 53"/>
-          <p:cNvSpPr txBox="1"/>
-          <p:nvPr/>
-        </p:nvSpPr>
-        <p:spPr>
-          <a:xfrm>
-            <a:off x="457200" y="2011680"/>
-            <a:ext cx="3931920" cy="685800"/>
-          </a:xfrm>
-          <a:prstGeom prst="rect">
-            <a:avLst/>
-          </a:prstGeom>
-          <a:noFill/>
-          <a:ln/>
-        </p:spPr>
-        <p:txBody>
-          <a:bodyPr wrap="square" lIns="0" tIns="0" rIns="0" bIns="0" rtlCol="0" anchor="ctr"/>
-          <a:lstStyle/>
-          <a:p>
-            <a:pPr indent="0" marL="0">
-              <a:buNone/>
-            </a:pPr>
-            <a:r>
-              <a:rPr lang="en-US" sz="2000" b="1" i="1" dirty="0">
-                <a:solidFill>
-                  <a:srgbClr val="6C63FF"/>
-                </a:solidFill>
-                <a:latin typeface="Calibri" pitchFamily="34" charset="0"/>
-                <a:ea typeface="Calibri" pitchFamily="34" charset="-122"/>
-                <a:cs typeface="Calibri" pitchFamily="34" charset="-120"/>
-              </a:rPr>
-              <a:t>The magic box that asks: where should it go?</a:t>
-            </a:r>
-            <a:endParaRPr lang="en-US" sz="2000" dirty="0"/>
-          </a:p>
-        </p:txBody>
-      </p:sp>
-      <p:sp>
-        <p:nvSpPr>
-          <p:cNvPr id="7" name="Text 54"/>
-          <p:cNvSpPr txBox="1"/>
-          <p:nvPr/>
-        </p:nvSpPr>
-        <p:spPr>
-          <a:xfrm>
-            <a:off x="457200" y="2743200"/>
-            <a:ext cx="3931920" cy="2194560"/>
-          </a:xfrm>
-          <a:prstGeom prst="rect">
-            <a:avLst/>
-          </a:prstGeom>
-          <a:noFill/>
-          <a:ln/>
-        </p:spPr>
-        <p:txBody>
-          <a:bodyPr wrap="square" lIns="0" tIns="0" rIns="0" bIns="0" rtlCol="0" anchor="t"/>
-          <a:lstStyle/>
-          <a:p>
-            <a:pPr indent="0" marL="0">
-              <a:buNone/>
-            </a:pPr>
-            <a:r>
-              <a:rPr lang="en-US" sz="1800" b="1" dirty="0">
-                <a:solidFill>
-                  <a:srgbClr val="6C63FF"/>
-                </a:solidFill>
-                <a:latin typeface="Calibri" pitchFamily="34" charset="0"/>
-                <a:ea typeface="Calibri" pitchFamily="34" charset="-122"/>
-                <a:cs typeface="Calibri" pitchFamily="34" charset="-120"/>
-              </a:rPr>
-              <a:t>1 </a:t>
-            </a:r>
-            <a:pPr indent="0" marL="0">
-              <a:spcAft>
-                <a:spcPts val="1000"/>
-              </a:spcAft>
-              <a:buNone/>
-            </a:pPr>
-            <a:r>
-              <a:rPr lang="en-US" sz="1800" dirty="0">
-                <a:solidFill>
-                  <a:schemeClr val="tx1"/>
-                </a:solidFill>
-                <a:latin typeface="Calibri" pitchFamily="34" charset="0"/>
-                <a:ea typeface="Calibri" pitchFamily="34" charset="-122"/>
-                <a:cs typeface="Calibri" pitchFamily="34" charset="-120"/>
-              </a:rPr>
-              <a:t>Look at the top: click Documents, then YOUR folder.</a:t>
-            </a:r>
-            <a:endParaRPr lang="en-US" sz="1800" dirty="0"/>
-          </a:p>
-          <a:p>
-            <a:pPr indent="0" marL="0">
-              <a:buNone/>
-            </a:pPr>
-            <a:r>
-              <a:rPr lang="en-US" sz="1800" b="1" dirty="0">
-                <a:solidFill>
-                  <a:srgbClr val="6C63FF"/>
-                </a:solidFill>
-                <a:latin typeface="Calibri" pitchFamily="34" charset="0"/>
-                <a:ea typeface="Calibri" pitchFamily="34" charset="-122"/>
-                <a:cs typeface="Calibri" pitchFamily="34" charset="-120"/>
-              </a:rPr>
-              <a:t>2 </a:t>
-            </a:r>
-            <a:pPr indent="0" marL="0">
-              <a:spcAft>
-                <a:spcPts val="1000"/>
-              </a:spcAft>
-              <a:buNone/>
-            </a:pPr>
-            <a:r>
-              <a:rPr lang="en-US" sz="1800" dirty="0">
-                <a:solidFill>
-                  <a:schemeClr val="tx1"/>
-                </a:solidFill>
-                <a:latin typeface="Calibri" pitchFamily="34" charset="0"/>
-                <a:ea typeface="Calibri" pitchFamily="34" charset="-122"/>
-                <a:cs typeface="Calibri" pitchFamily="34" charset="-120"/>
-              </a:rPr>
-              <a:t>Check the file name.</a:t>
-            </a:r>
-            <a:endParaRPr lang="en-US" sz="1800" dirty="0"/>
-          </a:p>
-          <a:p>
-            <a:pPr indent="0" marL="0">
-              <a:buNone/>
-            </a:pPr>
-            <a:r>
-              <a:rPr lang="en-US" sz="1800" b="1" dirty="0">
-                <a:solidFill>
-                  <a:srgbClr val="6C63FF"/>
-                </a:solidFill>
-                <a:latin typeface="Calibri" pitchFamily="34" charset="0"/>
-                <a:ea typeface="Calibri" pitchFamily="34" charset="-122"/>
-                <a:cs typeface="Calibri" pitchFamily="34" charset="-120"/>
-              </a:rPr>
-              <a:t>3 </a:t>
-            </a:r>
-            <a:pPr indent="0" marL="0">
-              <a:spcAft>
-                <a:spcPts val="1000"/>
-              </a:spcAft>
-              <a:buNone/>
-            </a:pPr>
-            <a:r>
-              <a:rPr lang="en-US" sz="1800" dirty="0">
-                <a:solidFill>
-                  <a:schemeClr val="tx1"/>
-                </a:solidFill>
-                <a:latin typeface="Calibri" pitchFamily="34" charset="0"/>
-                <a:ea typeface="Calibri" pitchFamily="34" charset="-122"/>
-                <a:cs typeface="Calibri" pitchFamily="34" charset="-120"/>
-              </a:rPr>
-              <a:t>Press Save!</a:t>
-            </a:r>
-            <a:endParaRPr lang="en-US" sz="1800" dirty="0"/>
-          </a:p>
-        </p:txBody>
-      </p:sp>
-      <p:sp>
-        <p:nvSpPr>
-          <p:cNvPr id="8" name="Card 55"/>
-          <p:cNvSpPr/>
-          <p:nvPr/>
-        </p:nvSpPr>
-        <p:spPr>
-          <a:xfrm>
-            <a:off x="4434840" y="1097280"/>
-            <a:ext cx="4389120" cy="3127248"/>
-          </a:xfrm>
-          <a:prstGeom prst="roundRect">
-            <a:avLst>
-              <a:gd name="adj" fmla="val 3509"/>
-            </a:avLst>
-          </a:prstGeom>
-          <a:solidFill>
-            <a:srgbClr val="FFFFFF"/>
-          </a:solidFill>
-          <a:ln/>
-          <a:effectLst>
-            <a:outerShdw sx="100000" sy="100000" kx="0" ky="0" algn="bl" rotWithShape="0" blurRad="76200" dist="25400" dir="5400000">
-              <a:srgbClr val="2B2250">
-                <a:alpha val="15000"/>
-              </a:srgbClr>
-            </a:outerShdw>
-          </a:effectLst>
-        </p:spPr>
       </p:sp>
       <p:pic>
         <p:nvPicPr>
-          <p:cNvPr id="9" name="Picture 56" descr="Save As box with three numbered steps">    </p:cNvPr>
+          <p:cNvPr id="4" name="Image 0" descr="/tmp/claude-0/-home-claude/14c3e32a-71e8-510d-8ed6-ad99b5ed7597/scratchpad/shots/w4.png">    </p:cNvPr>
           <p:cNvPicPr>
             <a:picLocks noChangeAspect="1"/>
           </p:cNvPicPr>
@@ -8347,14 +7831,424 @@
         </p:blipFill>
         <p:spPr>
           <a:xfrm>
-            <a:off x="4526280" y="1188720"/>
-            <a:ext cx="4206240" cy="2944368"/>
+            <a:off x="365760" y="1188720"/>
+            <a:ext cx="4389120" cy="3285744"/>
           </a:xfrm>
           <a:prstGeom prst="rect">
             <a:avLst/>
           </a:prstGeom>
         </p:spPr>
       </p:pic>
+      <p:sp>
+        <p:nvSpPr>
+          <p:cNvPr id="5" name="Shape 2"/>
+          <p:cNvSpPr/>
+          <p:nvPr/>
+        </p:nvSpPr>
+        <p:spPr>
+          <a:xfrm>
+            <a:off x="365760" y="1188720"/>
+            <a:ext cx="4389120" cy="3285744"/>
+          </a:xfrm>
+          <a:prstGeom prst="rect">
+            <a:avLst/>
+          </a:prstGeom>
+          <a:ln w="12700">
+            <a:solidFill>
+              <a:srgbClr val="B9B3D6"/>
+            </a:solidFill>
+            <a:prstDash val="solid"/>
+          </a:ln>
+        </p:spPr>
+      </p:sp>
+      <p:sp>
+        <p:nvSpPr>
+          <p:cNvPr id="6" name="Shape 3"/>
+          <p:cNvSpPr/>
+          <p:nvPr/>
+        </p:nvSpPr>
+        <p:spPr>
+          <a:xfrm>
+            <a:off x="1335024" y="1426464"/>
+            <a:ext cx="1566672" cy="207264"/>
+          </a:xfrm>
+          <a:prstGeom prst="roundRect">
+            <a:avLst>
+              <a:gd name="adj" fmla="val 26471"/>
+            </a:avLst>
+          </a:prstGeom>
+          <a:ln w="44450">
+            <a:solidFill>
+              <a:srgbClr val="FF5C8A"/>
+            </a:solidFill>
+            <a:prstDash val="solid"/>
+          </a:ln>
+        </p:spPr>
+      </p:sp>
+      <p:sp>
+        <p:nvSpPr>
+          <p:cNvPr id="7" name="Shape 4"/>
+          <p:cNvSpPr/>
+          <p:nvPr/>
+        </p:nvSpPr>
+        <p:spPr>
+          <a:xfrm>
+            <a:off x="1188720" y="1280160"/>
+            <a:ext cx="347472" cy="347472"/>
+          </a:xfrm>
+          <a:prstGeom prst="ellipse">
+            <a:avLst/>
+          </a:prstGeom>
+          <a:solidFill>
+            <a:srgbClr val="FF5C8A"/>
+          </a:solidFill>
+          <a:ln w="19050">
+            <a:solidFill>
+              <a:srgbClr val="FFFFFF"/>
+            </a:solidFill>
+            <a:prstDash val="solid"/>
+          </a:ln>
+        </p:spPr>
+      </p:sp>
+      <p:sp>
+        <p:nvSpPr>
+          <p:cNvPr id="8" name="Text 39"/>
+          <p:cNvSpPr txBox="1"/>
+          <p:nvPr/>
+        </p:nvSpPr>
+        <p:spPr>
+          <a:xfrm>
+            <a:off x="1188720" y="1280160"/>
+            <a:ext cx="347472" cy="347472"/>
+          </a:xfrm>
+          <a:prstGeom prst="rect">
+            <a:avLst/>
+          </a:prstGeom>
+          <a:noFill/>
+          <a:ln/>
+        </p:spPr>
+        <p:txBody>
+          <a:bodyPr wrap="square" lIns="0" tIns="0" rIns="0" bIns="0" rtlCol="0" anchor="ctr"/>
+          <a:lstStyle/>
+          <a:p>
+            <a:pPr algn="ctr" indent="0" marL="0">
+              <a:buNone/>
+            </a:pPr>
+            <a:r>
+              <a:rPr lang="en-US" sz="1600" b="1" dirty="0">
+                <a:solidFill>
+                  <a:srgbClr val="FFFFFF"/>
+                </a:solidFill>
+                <a:latin typeface="Calibri" pitchFamily="34" charset="0"/>
+                <a:ea typeface="Calibri" pitchFamily="34" charset="-122"/>
+                <a:cs typeface="Calibri" pitchFamily="34" charset="-120"/>
+              </a:rPr>
+              <a:t>1</a:t>
+            </a:r>
+            <a:endParaRPr lang="en-US" sz="1600" dirty="0"/>
+          </a:p>
+        </p:txBody>
+      </p:sp>
+      <p:sp>
+        <p:nvSpPr>
+          <p:cNvPr id="9" name="Shape 6"/>
+          <p:cNvSpPr/>
+          <p:nvPr/>
+        </p:nvSpPr>
+        <p:spPr>
+          <a:xfrm>
+            <a:off x="682752" y="3236976"/>
+            <a:ext cx="4078224" cy="213360"/>
+          </a:xfrm>
+          <a:prstGeom prst="roundRect">
+            <a:avLst>
+              <a:gd name="adj" fmla="val 25714"/>
+            </a:avLst>
+          </a:prstGeom>
+          <a:ln w="44450">
+            <a:solidFill>
+              <a:srgbClr val="FF9A3D"/>
+            </a:solidFill>
+            <a:prstDash val="solid"/>
+          </a:ln>
+        </p:spPr>
+      </p:sp>
+      <p:sp>
+        <p:nvSpPr>
+          <p:cNvPr id="10" name="Shape 7"/>
+          <p:cNvSpPr/>
+          <p:nvPr/>
+        </p:nvSpPr>
+        <p:spPr>
+          <a:xfrm>
+            <a:off x="536448" y="3090672"/>
+            <a:ext cx="347472" cy="347472"/>
+          </a:xfrm>
+          <a:prstGeom prst="ellipse">
+            <a:avLst/>
+          </a:prstGeom>
+          <a:solidFill>
+            <a:srgbClr val="FF9A3D"/>
+          </a:solidFill>
+          <a:ln w="19050">
+            <a:solidFill>
+              <a:srgbClr val="FFFFFF"/>
+            </a:solidFill>
+            <a:prstDash val="solid"/>
+          </a:ln>
+        </p:spPr>
+      </p:sp>
+      <p:sp>
+        <p:nvSpPr>
+          <p:cNvPr id="11" name="Text 40"/>
+          <p:cNvSpPr txBox="1"/>
+          <p:nvPr/>
+        </p:nvSpPr>
+        <p:spPr>
+          <a:xfrm>
+            <a:off x="536448" y="3090672"/>
+            <a:ext cx="347472" cy="347472"/>
+          </a:xfrm>
+          <a:prstGeom prst="rect">
+            <a:avLst/>
+          </a:prstGeom>
+          <a:noFill/>
+          <a:ln/>
+        </p:spPr>
+        <p:txBody>
+          <a:bodyPr wrap="square" lIns="0" tIns="0" rIns="0" bIns="0" rtlCol="0" anchor="ctr"/>
+          <a:lstStyle/>
+          <a:p>
+            <a:pPr algn="ctr" indent="0" marL="0">
+              <a:buNone/>
+            </a:pPr>
+            <a:r>
+              <a:rPr lang="en-US" sz="1600" b="1" dirty="0">
+                <a:solidFill>
+                  <a:srgbClr val="FFFFFF"/>
+                </a:solidFill>
+                <a:latin typeface="Calibri" pitchFamily="34" charset="0"/>
+                <a:ea typeface="Calibri" pitchFamily="34" charset="-122"/>
+                <a:cs typeface="Calibri" pitchFamily="34" charset="-120"/>
+              </a:rPr>
+              <a:t>2</a:t>
+            </a:r>
+            <a:endParaRPr lang="en-US" sz="1600" dirty="0"/>
+          </a:p>
+        </p:txBody>
+      </p:sp>
+      <p:sp>
+        <p:nvSpPr>
+          <p:cNvPr id="12" name="Shape 9"/>
+          <p:cNvSpPr/>
+          <p:nvPr/>
+        </p:nvSpPr>
+        <p:spPr>
+          <a:xfrm>
+            <a:off x="3297936" y="4139184"/>
+            <a:ext cx="682752" cy="243840"/>
+          </a:xfrm>
+          <a:prstGeom prst="roundRect">
+            <a:avLst>
+              <a:gd name="adj" fmla="val 22500"/>
+            </a:avLst>
+          </a:prstGeom>
+          <a:ln w="44450">
+            <a:solidFill>
+              <a:srgbClr val="2E9E5B"/>
+            </a:solidFill>
+            <a:prstDash val="solid"/>
+          </a:ln>
+        </p:spPr>
+      </p:sp>
+      <p:sp>
+        <p:nvSpPr>
+          <p:cNvPr id="13" name="Shape 10"/>
+          <p:cNvSpPr/>
+          <p:nvPr/>
+        </p:nvSpPr>
+        <p:spPr>
+          <a:xfrm>
+            <a:off x="3151632" y="3992880"/>
+            <a:ext cx="347472" cy="347472"/>
+          </a:xfrm>
+          <a:prstGeom prst="ellipse">
+            <a:avLst/>
+          </a:prstGeom>
+          <a:solidFill>
+            <a:srgbClr val="2E9E5B"/>
+          </a:solidFill>
+          <a:ln w="19050">
+            <a:solidFill>
+              <a:srgbClr val="FFFFFF"/>
+            </a:solidFill>
+            <a:prstDash val="solid"/>
+          </a:ln>
+        </p:spPr>
+      </p:sp>
+      <p:sp>
+        <p:nvSpPr>
+          <p:cNvPr id="14" name="Text 41"/>
+          <p:cNvSpPr txBox="1"/>
+          <p:nvPr/>
+        </p:nvSpPr>
+        <p:spPr>
+          <a:xfrm>
+            <a:off x="3151632" y="3992880"/>
+            <a:ext cx="347472" cy="347472"/>
+          </a:xfrm>
+          <a:prstGeom prst="rect">
+            <a:avLst/>
+          </a:prstGeom>
+          <a:noFill/>
+          <a:ln/>
+        </p:spPr>
+        <p:txBody>
+          <a:bodyPr wrap="square" lIns="0" tIns="0" rIns="0" bIns="0" rtlCol="0" anchor="ctr"/>
+          <a:lstStyle/>
+          <a:p>
+            <a:pPr algn="ctr" indent="0" marL="0">
+              <a:buNone/>
+            </a:pPr>
+            <a:r>
+              <a:rPr lang="en-US" sz="1600" b="1" dirty="0">
+                <a:solidFill>
+                  <a:srgbClr val="FFFFFF"/>
+                </a:solidFill>
+                <a:latin typeface="Calibri" pitchFamily="34" charset="0"/>
+                <a:ea typeface="Calibri" pitchFamily="34" charset="-122"/>
+                <a:cs typeface="Calibri" pitchFamily="34" charset="-120"/>
+              </a:rPr>
+              <a:t>3</a:t>
+            </a:r>
+            <a:endParaRPr lang="en-US" sz="1600" dirty="0"/>
+          </a:p>
+        </p:txBody>
+      </p:sp>
+      <p:sp>
+        <p:nvSpPr>
+          <p:cNvPr id="15" name="Text 42"/>
+          <p:cNvSpPr txBox="1"/>
+          <p:nvPr/>
+        </p:nvSpPr>
+        <p:spPr>
+          <a:xfrm>
+            <a:off x="4937760" y="1463040"/>
+            <a:ext cx="3931920" cy="2926080"/>
+          </a:xfrm>
+          <a:prstGeom prst="rect">
+            <a:avLst/>
+          </a:prstGeom>
+          <a:noFill/>
+          <a:ln/>
+        </p:spPr>
+        <p:txBody>
+          <a:bodyPr wrap="square" lIns="0" tIns="0" rIns="0" bIns="0" rtlCol="0" anchor="t"/>
+          <a:lstStyle/>
+          <a:p>
+            <a:pPr indent="0" marL="0">
+              <a:buNone/>
+            </a:pPr>
+            <a:r>
+              <a:rPr lang="en-US" sz="2000" b="1" dirty="0">
+                <a:solidFill>
+                  <a:srgbClr val="6C63FF"/>
+                </a:solidFill>
+                <a:latin typeface="Calibri" pitchFamily="34" charset="0"/>
+                <a:ea typeface="Calibri" pitchFamily="34" charset="-122"/>
+                <a:cs typeface="Calibri" pitchFamily="34" charset="-120"/>
+              </a:rPr>
+              <a:t>1 </a:t>
+            </a:r>
+            <a:pPr indent="0" marL="0">
+              <a:spcAft>
+                <a:spcPts val="800"/>
+              </a:spcAft>
+              <a:buNone/>
+            </a:pPr>
+            <a:r>
+              <a:rPr lang="en-US" sz="2000" dirty="0">
+                <a:solidFill>
+                  <a:schemeClr val="tx1"/>
+                </a:solidFill>
+                <a:latin typeface="Calibri" pitchFamily="34" charset="0"/>
+                <a:ea typeface="Calibri" pitchFamily="34" charset="-122"/>
+                <a:cs typeface="Calibri" pitchFamily="34" charset="-120"/>
+              </a:rPr>
+              <a:t>Check the top says Documents › your folder.</a:t>
+            </a:r>
+            <a:endParaRPr lang="en-US" sz="1800" dirty="0"/>
+          </a:p>
+          <a:p>
+            <a:pPr indent="0" marL="0">
+              <a:buNone/>
+            </a:pPr>
+            <a:r>
+              <a:rPr lang="en-US" sz="2000" b="1" dirty="0">
+                <a:solidFill>
+                  <a:srgbClr val="6C63FF"/>
+                </a:solidFill>
+                <a:latin typeface="Calibri" pitchFamily="34" charset="0"/>
+                <a:ea typeface="Calibri" pitchFamily="34" charset="-122"/>
+                <a:cs typeface="Calibri" pitchFamily="34" charset="-120"/>
+              </a:rPr>
+              <a:t>2 </a:t>
+            </a:r>
+            <a:pPr indent="0" marL="0">
+              <a:spcAft>
+                <a:spcPts val="800"/>
+              </a:spcAft>
+              <a:buNone/>
+            </a:pPr>
+            <a:r>
+              <a:rPr lang="en-US" sz="2000" dirty="0">
+                <a:solidFill>
+                  <a:schemeClr val="tx1"/>
+                </a:solidFill>
+                <a:latin typeface="Calibri" pitchFamily="34" charset="0"/>
+                <a:ea typeface="Calibri" pitchFamily="34" charset="-122"/>
+                <a:cs typeface="Calibri" pitchFamily="34" charset="-120"/>
+              </a:rPr>
+              <a:t>Check the file name.</a:t>
+            </a:r>
+            <a:endParaRPr lang="en-US" sz="1800" dirty="0"/>
+          </a:p>
+          <a:p>
+            <a:pPr indent="0" marL="0">
+              <a:buNone/>
+            </a:pPr>
+            <a:r>
+              <a:rPr lang="en-US" sz="2000" b="1" dirty="0">
+                <a:solidFill>
+                  <a:srgbClr val="6C63FF"/>
+                </a:solidFill>
+                <a:latin typeface="Calibri" pitchFamily="34" charset="0"/>
+                <a:ea typeface="Calibri" pitchFamily="34" charset="-122"/>
+                <a:cs typeface="Calibri" pitchFamily="34" charset="-120"/>
+              </a:rPr>
+              <a:t>3 </a:t>
+            </a:r>
+            <a:pPr indent="0" marL="0">
+              <a:spcAft>
+                <a:spcPts val="800"/>
+              </a:spcAft>
+              <a:buNone/>
+            </a:pPr>
+            <a:r>
+              <a:rPr lang="en-US" sz="2000" dirty="0">
+                <a:solidFill>
+                  <a:schemeClr val="tx1"/>
+                </a:solidFill>
+                <a:latin typeface="Calibri" pitchFamily="34" charset="0"/>
+                <a:ea typeface="Calibri" pitchFamily="34" charset="-122"/>
+                <a:cs typeface="Calibri" pitchFamily="34" charset="-120"/>
+              </a:rPr>
+              <a:t>Press Save!</a:t>
+            </a:r>
+            <a:endParaRPr lang="en-US" sz="1800" dirty="0"/>
+          </a:p>
+        </p:txBody>
+      </p:sp>
     </p:spTree>
   </p:cSld>
   <p:clrMapOvr>
@@ -8382,7 +8276,7 @@
       </p:grpSpPr>
       <p:sp>
         <p:nvSpPr>
-          <p:cNvPr id="2" name="Accent 57"/>
+          <p:cNvPr id="2" name="Accent 43"/>
           <p:cNvSpPr/>
           <p:nvPr/>
         </p:nvSpPr>
@@ -8407,7 +8301,7 @@
       </p:sp>
       <p:sp>
         <p:nvSpPr>
-          <p:cNvPr id="3" name="Text 58"/>
+          <p:cNvPr id="3" name="Text 44"/>
           <p:cNvSpPr txBox="1"/>
           <p:nvPr/>
         </p:nvSpPr>
@@ -8446,7 +8340,7 @@
       </p:sp>
       <p:sp>
         <p:nvSpPr>
-          <p:cNvPr id="4" name="Card 59"/>
+          <p:cNvPr id="4" name="Card 45"/>
           <p:cNvSpPr/>
           <p:nvPr/>
         </p:nvSpPr>
@@ -8475,7 +8369,7 @@
       </p:sp>
       <p:sp>
         <p:nvSpPr>
-          <p:cNvPr id="5" name="Text 60"/>
+          <p:cNvPr id="5" name="Text 46"/>
           <p:cNvSpPr txBox="1"/>
           <p:nvPr/>
         </p:nvSpPr>
@@ -8516,7 +8410,7 @@
       </p:sp>
       <p:sp>
         <p:nvSpPr>
-          <p:cNvPr id="6" name="Text 61"/>
+          <p:cNvPr id="6" name="Text 47"/>
           <p:cNvSpPr txBox="1"/>
           <p:nvPr/>
         </p:nvSpPr>
@@ -8555,7 +8449,7 @@
       </p:sp>
       <p:sp>
         <p:nvSpPr>
-          <p:cNvPr id="7" name="Text 62"/>
+          <p:cNvPr id="7" name="Text 48"/>
           <p:cNvSpPr txBox="1"/>
           <p:nvPr/>
         </p:nvSpPr>
@@ -8679,7 +8573,7 @@
       </p:sp>
       <p:sp>
         <p:nvSpPr>
-          <p:cNvPr id="8" name="Card 63"/>
+          <p:cNvPr id="8" name="Card 49"/>
           <p:cNvSpPr/>
           <p:nvPr/>
         </p:nvSpPr>
@@ -8708,7 +8602,7 @@
       </p:sp>
       <p:pic>
         <p:nvPicPr>
-          <p:cNvPr id="9" name="Picture 64" descr="Folder with a Word file inside">    </p:cNvPr>
+          <p:cNvPr id="9" name="Picture 50" descr="Folder with a Word file inside">    </p:cNvPr>
           <p:cNvPicPr>
             <a:picLocks noChangeAspect="1"/>
           </p:cNvPicPr>
@@ -8757,7 +8651,7 @@
       </p:grpSpPr>
       <p:sp>
         <p:nvSpPr>
-          <p:cNvPr id="2" name="Accent 65"/>
+          <p:cNvPr id="2" name="Accent 51"/>
           <p:cNvSpPr/>
           <p:nvPr/>
         </p:nvSpPr>
@@ -8782,7 +8676,7 @@
       </p:sp>
       <p:sp>
         <p:nvSpPr>
-          <p:cNvPr id="3" name="Text 66"/>
+          <p:cNvPr id="3" name="Text 52"/>
           <p:cNvSpPr txBox="1"/>
           <p:nvPr/>
         </p:nvSpPr>
@@ -8821,7 +8715,7 @@
       </p:sp>
       <p:sp>
         <p:nvSpPr>
-          <p:cNvPr id="4" name="Card 67"/>
+          <p:cNvPr id="4" name="Card 53"/>
           <p:cNvSpPr/>
           <p:nvPr/>
         </p:nvSpPr>
@@ -8850,7 +8744,7 @@
       </p:sp>
       <p:sp>
         <p:nvSpPr>
-          <p:cNvPr id="5" name="Text 68"/>
+          <p:cNvPr id="5" name="Text 54"/>
           <p:cNvSpPr txBox="1"/>
           <p:nvPr/>
         </p:nvSpPr>
@@ -8891,7 +8785,7 @@
       </p:sp>
       <p:sp>
         <p:nvSpPr>
-          <p:cNvPr id="6" name="Text 69"/>
+          <p:cNvPr id="6" name="Text 55"/>
           <p:cNvSpPr txBox="1"/>
           <p:nvPr/>
         </p:nvSpPr>
@@ -8930,7 +8824,7 @@
       </p:sp>
       <p:sp>
         <p:nvSpPr>
-          <p:cNvPr id="7" name="Text 70"/>
+          <p:cNvPr id="7" name="Text 56"/>
           <p:cNvSpPr txBox="1"/>
           <p:nvPr/>
         </p:nvSpPr>
@@ -9054,7 +8948,7 @@
       </p:sp>
       <p:sp>
         <p:nvSpPr>
-          <p:cNvPr id="8" name="Card 71"/>
+          <p:cNvPr id="8" name="Card 57"/>
           <p:cNvSpPr/>
           <p:nvPr/>
         </p:nvSpPr>
@@ -9083,7 +8977,7 @@
       </p:sp>
       <p:pic>
         <p:nvPicPr>
-          <p:cNvPr id="9" name="Picture 72" descr="Good and bad file names">    </p:cNvPr>
+          <p:cNvPr id="9" name="Picture 58" descr="Good and bad file names">    </p:cNvPr>
           <p:cNvPicPr>
             <a:picLocks noChangeAspect="1"/>
           </p:cNvPicPr>

</xml_diff>